<commit_message>
updated ppt after presentation
</commit_message>
<xml_diff>
--- a/Phase II Major Project(1).pptx
+++ b/Phase II Major Project(1).pptx
@@ -363,7 +363,7 @@
             <a:pPr indent="0" algn="r">
               <a:buNone/>
             </a:pPr>
-            <a:fld id="{66B2ABA7-FEC2-4DA0-8CEE-CF57990F2A03}" type="slidenum">
+            <a:fld id="{538975A9-EA23-4664-BE2F-C6EC016C8682}" type="slidenum">
               <a:rPr b="0" lang="en-US" sz="1400" spc="-1" strike="noStrike">
                 <a:solidFill>
                   <a:srgbClr val="000000"/>
@@ -417,7 +417,7 @@
         <p:spPr>
           <a:xfrm>
             <a:off x="6281640" y="847800"/>
-            <a:ext cx="7536600" cy="4237920"/>
+            <a:ext cx="7535520" cy="4236840"/>
           </a:xfrm>
           <a:prstGeom prst="rect">
             <a:avLst/>
@@ -440,7 +440,7 @@
         <p:spPr>
           <a:xfrm>
             <a:off x="2009880" y="5372280"/>
-            <a:ext cx="16080480" cy="5085720"/>
+            <a:ext cx="16079400" cy="5084640"/>
           </a:xfrm>
           <a:prstGeom prst="rect">
             <a:avLst/>
@@ -480,7 +480,7 @@
         <p:spPr>
           <a:xfrm>
             <a:off x="11387160" y="10742760"/>
-            <a:ext cx="8708400" cy="561240"/>
+            <a:ext cx="8707320" cy="560160"/>
           </a:xfrm>
           <a:prstGeom prst="rect">
             <a:avLst/>
@@ -522,7 +522,7 @@
                 <a:tab algn="l" pos="0"/>
               </a:tabLst>
             </a:pPr>
-            <a:fld id="{76F1B5F3-270C-4443-95E4-BF3DD469D627}" type="slidenum">
+            <a:fld id="{2A50F77E-578C-4384-B8D4-FA9E037B3B5D}" type="slidenum">
               <a:rPr b="0" lang="en-IN" sz="1200" spc="-1" strike="noStrike">
                 <a:solidFill>
                   <a:schemeClr val="dk1"/>
@@ -530,7 +530,7 @@
                 <a:latin typeface="Calibri"/>
                 <a:ea typeface="Calibri"/>
               </a:rPr>
-              <a:t>&lt;number&gt;</a:t>
+              <a:t>19</a:t>
             </a:fld>
             <a:endParaRPr b="0" lang="en-US" sz="1200" spc="-1" strike="noStrike">
               <a:solidFill>
@@ -576,7 +576,7 @@
         <p:spPr>
           <a:xfrm>
             <a:off x="6281640" y="847800"/>
-            <a:ext cx="7536600" cy="4237920"/>
+            <a:ext cx="7535520" cy="4236840"/>
           </a:xfrm>
           <a:prstGeom prst="rect">
             <a:avLst/>
@@ -599,7 +599,7 @@
         <p:spPr>
           <a:xfrm>
             <a:off x="2009880" y="5372280"/>
-            <a:ext cx="16080480" cy="5085720"/>
+            <a:ext cx="16079400" cy="5084640"/>
           </a:xfrm>
           <a:prstGeom prst="rect">
             <a:avLst/>
@@ -639,7 +639,7 @@
         <p:spPr>
           <a:xfrm>
             <a:off x="11387160" y="10742760"/>
-            <a:ext cx="8708400" cy="561240"/>
+            <a:ext cx="8707320" cy="560160"/>
           </a:xfrm>
           <a:prstGeom prst="rect">
             <a:avLst/>
@@ -681,7 +681,7 @@
                 <a:tab algn="l" pos="0"/>
               </a:tabLst>
             </a:pPr>
-            <a:fld id="{38F0F453-454B-4D03-B703-1598769C37C4}" type="slidenum">
+            <a:fld id="{D558864C-FCD7-41B5-A1F3-F25253D2ADDC}" type="slidenum">
               <a:rPr b="0" lang="en-IN" sz="1200" spc="-1" strike="noStrike">
                 <a:solidFill>
                   <a:schemeClr val="dk1"/>
@@ -735,7 +735,7 @@
         <p:spPr>
           <a:xfrm>
             <a:off x="6281640" y="847800"/>
-            <a:ext cx="7536600" cy="4237920"/>
+            <a:ext cx="7535520" cy="4236840"/>
           </a:xfrm>
           <a:prstGeom prst="rect">
             <a:avLst/>
@@ -758,7 +758,7 @@
         <p:spPr>
           <a:xfrm>
             <a:off x="2009880" y="5372280"/>
-            <a:ext cx="16080480" cy="5085720"/>
+            <a:ext cx="16079400" cy="5084640"/>
           </a:xfrm>
           <a:prstGeom prst="rect">
             <a:avLst/>
@@ -798,7 +798,7 @@
         <p:spPr>
           <a:xfrm>
             <a:off x="11387160" y="10742760"/>
-            <a:ext cx="8708400" cy="561240"/>
+            <a:ext cx="8707320" cy="560160"/>
           </a:xfrm>
           <a:prstGeom prst="rect">
             <a:avLst/>
@@ -840,7 +840,7 @@
                 <a:tab algn="l" pos="0"/>
               </a:tabLst>
             </a:pPr>
-            <a:fld id="{684F5869-DFC9-4996-8619-F1E17B19843E}" type="slidenum">
+            <a:fld id="{39A82331-4238-4494-A623-EB4459FB47F2}" type="slidenum">
               <a:rPr b="0" lang="en-IN" sz="1200" spc="-1" strike="noStrike">
                 <a:solidFill>
                   <a:schemeClr val="dk1"/>
@@ -894,7 +894,7 @@
         <p:spPr>
           <a:xfrm>
             <a:off x="6281640" y="847800"/>
-            <a:ext cx="7536600" cy="4237920"/>
+            <a:ext cx="7535520" cy="4236840"/>
           </a:xfrm>
           <a:prstGeom prst="rect">
             <a:avLst/>
@@ -917,7 +917,7 @@
         <p:spPr>
           <a:xfrm>
             <a:off x="2009880" y="5372280"/>
-            <a:ext cx="16080480" cy="5085720"/>
+            <a:ext cx="16079400" cy="5084640"/>
           </a:xfrm>
           <a:prstGeom prst="rect">
             <a:avLst/>
@@ -957,7 +957,7 @@
         <p:spPr>
           <a:xfrm>
             <a:off x="11387160" y="10742760"/>
-            <a:ext cx="8708400" cy="561240"/>
+            <a:ext cx="8707320" cy="560160"/>
           </a:xfrm>
           <a:prstGeom prst="rect">
             <a:avLst/>
@@ -999,7 +999,7 @@
                 <a:tab algn="l" pos="0"/>
               </a:tabLst>
             </a:pPr>
-            <a:fld id="{BE023B63-C8CA-4759-95FB-B85CB8104A8C}" type="slidenum">
+            <a:fld id="{D085DCDC-F33B-41FB-B1C8-D6203209A5D8}" type="slidenum">
               <a:rPr b="0" lang="en-IN" sz="1200" spc="-1" strike="noStrike">
                 <a:solidFill>
                   <a:schemeClr val="dk1"/>
@@ -1053,7 +1053,7 @@
         <p:spPr>
           <a:xfrm>
             <a:off x="6281640" y="847800"/>
-            <a:ext cx="7536600" cy="4237920"/>
+            <a:ext cx="7535520" cy="4236840"/>
           </a:xfrm>
           <a:prstGeom prst="rect">
             <a:avLst/>
@@ -1076,7 +1076,7 @@
         <p:spPr>
           <a:xfrm>
             <a:off x="2009880" y="5372280"/>
-            <a:ext cx="16080480" cy="5085720"/>
+            <a:ext cx="16079400" cy="5084640"/>
           </a:xfrm>
           <a:prstGeom prst="rect">
             <a:avLst/>
@@ -1116,7 +1116,7 @@
         <p:spPr>
           <a:xfrm>
             <a:off x="11387160" y="10742760"/>
-            <a:ext cx="8708400" cy="561240"/>
+            <a:ext cx="8707320" cy="560160"/>
           </a:xfrm>
           <a:prstGeom prst="rect">
             <a:avLst/>
@@ -1158,7 +1158,7 @@
                 <a:tab algn="l" pos="0"/>
               </a:tabLst>
             </a:pPr>
-            <a:fld id="{11D8210E-CEAD-4D0D-9E8E-5864ECE0BC09}" type="slidenum">
+            <a:fld id="{EF494AD6-A120-4EB0-9705-70C4C22B58E4}" type="slidenum">
               <a:rPr b="0" lang="en-IN" sz="1200" spc="-1" strike="noStrike">
                 <a:solidFill>
                   <a:schemeClr val="dk1"/>
@@ -1212,7 +1212,7 @@
         <p:spPr>
           <a:xfrm>
             <a:off x="6281640" y="847800"/>
-            <a:ext cx="7536600" cy="4237920"/>
+            <a:ext cx="7535520" cy="4236840"/>
           </a:xfrm>
           <a:prstGeom prst="rect">
             <a:avLst/>
@@ -1235,7 +1235,7 @@
         <p:spPr>
           <a:xfrm>
             <a:off x="2009880" y="5372280"/>
-            <a:ext cx="16080480" cy="5085720"/>
+            <a:ext cx="16079400" cy="5084640"/>
           </a:xfrm>
           <a:prstGeom prst="rect">
             <a:avLst/>
@@ -1275,7 +1275,7 @@
         <p:spPr>
           <a:xfrm>
             <a:off x="11387160" y="10742760"/>
-            <a:ext cx="8708400" cy="561240"/>
+            <a:ext cx="8707320" cy="560160"/>
           </a:xfrm>
           <a:prstGeom prst="rect">
             <a:avLst/>
@@ -1317,7 +1317,7 @@
                 <a:tab algn="l" pos="0"/>
               </a:tabLst>
             </a:pPr>
-            <a:fld id="{CD4149B4-BAEF-4399-89FD-0E744B4AF55B}" type="slidenum">
+            <a:fld id="{642825EE-104F-4384-844B-674795ABAB40}" type="slidenum">
               <a:rPr b="0" lang="en-IN" sz="1200" spc="-1" strike="noStrike">
                 <a:solidFill>
                   <a:schemeClr val="dk1"/>
@@ -1371,7 +1371,7 @@
         <p:spPr>
           <a:xfrm>
             <a:off x="6281640" y="847800"/>
-            <a:ext cx="7536600" cy="4237920"/>
+            <a:ext cx="7535520" cy="4236840"/>
           </a:xfrm>
           <a:prstGeom prst="rect">
             <a:avLst/>
@@ -1394,7 +1394,7 @@
         <p:spPr>
           <a:xfrm>
             <a:off x="2009880" y="5372280"/>
-            <a:ext cx="16080480" cy="5085720"/>
+            <a:ext cx="16079400" cy="5084640"/>
           </a:xfrm>
           <a:prstGeom prst="rect">
             <a:avLst/>
@@ -1434,7 +1434,7 @@
         <p:spPr>
           <a:xfrm>
             <a:off x="11387160" y="10742760"/>
-            <a:ext cx="8708400" cy="561240"/>
+            <a:ext cx="8707320" cy="560160"/>
           </a:xfrm>
           <a:prstGeom prst="rect">
             <a:avLst/>
@@ -1476,7 +1476,7 @@
                 <a:tab algn="l" pos="0"/>
               </a:tabLst>
             </a:pPr>
-            <a:fld id="{1DDDB2D9-5A42-4ED7-BC4A-5E9932C49A85}" type="slidenum">
+            <a:fld id="{E0203D49-6310-452A-9AAF-EDE38761806D}" type="slidenum">
               <a:rPr b="0" lang="en-IN" sz="1200" spc="-1" strike="noStrike">
                 <a:solidFill>
                   <a:schemeClr val="dk1"/>
@@ -1530,7 +1530,7 @@
         <p:spPr>
           <a:xfrm>
             <a:off x="6281640" y="847800"/>
-            <a:ext cx="7536600" cy="4237920"/>
+            <a:ext cx="7535520" cy="4236840"/>
           </a:xfrm>
           <a:prstGeom prst="rect">
             <a:avLst/>
@@ -1553,7 +1553,7 @@
         <p:spPr>
           <a:xfrm>
             <a:off x="2009880" y="5372280"/>
-            <a:ext cx="16080480" cy="5085720"/>
+            <a:ext cx="16079400" cy="5084640"/>
           </a:xfrm>
           <a:prstGeom prst="rect">
             <a:avLst/>
@@ -1593,7 +1593,7 @@
         <p:spPr>
           <a:xfrm>
             <a:off x="11387160" y="10742760"/>
-            <a:ext cx="8708400" cy="561240"/>
+            <a:ext cx="8707320" cy="560160"/>
           </a:xfrm>
           <a:prstGeom prst="rect">
             <a:avLst/>
@@ -1635,7 +1635,7 @@
                 <a:tab algn="l" pos="0"/>
               </a:tabLst>
             </a:pPr>
-            <a:fld id="{7EEE3703-5345-4F81-B320-77D2927E59C1}" type="slidenum">
+            <a:fld id="{725B865D-04FC-47F7-9BDD-D8839B4E8BA5}" type="slidenum">
               <a:rPr b="0" lang="en-IN" sz="1200" spc="-1" strike="noStrike">
                 <a:solidFill>
                   <a:schemeClr val="dk1"/>
@@ -1689,7 +1689,7 @@
         <p:spPr>
           <a:xfrm>
             <a:off x="6281640" y="847800"/>
-            <a:ext cx="7536600" cy="4237920"/>
+            <a:ext cx="7535520" cy="4236840"/>
           </a:xfrm>
           <a:prstGeom prst="rect">
             <a:avLst/>
@@ -1712,7 +1712,7 @@
         <p:spPr>
           <a:xfrm>
             <a:off x="2009880" y="5372280"/>
-            <a:ext cx="16080480" cy="5085720"/>
+            <a:ext cx="16079400" cy="5084640"/>
           </a:xfrm>
           <a:prstGeom prst="rect">
             <a:avLst/>
@@ -1752,7 +1752,7 @@
         <p:spPr>
           <a:xfrm>
             <a:off x="11387160" y="10742760"/>
-            <a:ext cx="8708400" cy="561240"/>
+            <a:ext cx="8707320" cy="560160"/>
           </a:xfrm>
           <a:prstGeom prst="rect">
             <a:avLst/>
@@ -1794,7 +1794,7 @@
                 <a:tab algn="l" pos="0"/>
               </a:tabLst>
             </a:pPr>
-            <a:fld id="{F1F54CEE-CACE-4A97-B2E6-71A67648BAB1}" type="slidenum">
+            <a:fld id="{D68137C6-F2FA-452E-B144-8BFC6CE3B4D3}" type="slidenum">
               <a:rPr b="0" lang="en-IN" sz="1200" spc="-1" strike="noStrike">
                 <a:solidFill>
                   <a:schemeClr val="dk1"/>
@@ -1848,7 +1848,7 @@
         <p:spPr>
           <a:xfrm>
             <a:off x="6281640" y="847800"/>
-            <a:ext cx="7536600" cy="4237920"/>
+            <a:ext cx="7535520" cy="4236840"/>
           </a:xfrm>
           <a:prstGeom prst="rect">
             <a:avLst/>
@@ -1871,7 +1871,7 @@
         <p:spPr>
           <a:xfrm>
             <a:off x="2009880" y="5372280"/>
-            <a:ext cx="16080480" cy="5085720"/>
+            <a:ext cx="16079400" cy="5084640"/>
           </a:xfrm>
           <a:prstGeom prst="rect">
             <a:avLst/>
@@ -1911,7 +1911,7 @@
         <p:spPr>
           <a:xfrm>
             <a:off x="11387160" y="10742760"/>
-            <a:ext cx="8708400" cy="561240"/>
+            <a:ext cx="8707320" cy="560160"/>
           </a:xfrm>
           <a:prstGeom prst="rect">
             <a:avLst/>
@@ -1953,7 +1953,7 @@
                 <a:tab algn="l" pos="0"/>
               </a:tabLst>
             </a:pPr>
-            <a:fld id="{9940CA79-7D6D-4DFC-8B62-6388B3315EAD}" type="slidenum">
+            <a:fld id="{AB9E6523-19CA-4EEB-B789-099C482EB304}" type="slidenum">
               <a:rPr b="0" lang="en-IN" sz="1200" spc="-1" strike="noStrike">
                 <a:solidFill>
                   <a:schemeClr val="dk1"/>
@@ -2007,7 +2007,7 @@
         <p:spPr>
           <a:xfrm>
             <a:off x="6281640" y="847800"/>
-            <a:ext cx="7536600" cy="4237920"/>
+            <a:ext cx="7535520" cy="4236840"/>
           </a:xfrm>
           <a:prstGeom prst="rect">
             <a:avLst/>
@@ -2030,7 +2030,7 @@
         <p:spPr>
           <a:xfrm>
             <a:off x="2009880" y="5372280"/>
-            <a:ext cx="16080480" cy="5085720"/>
+            <a:ext cx="16079400" cy="5084640"/>
           </a:xfrm>
           <a:prstGeom prst="rect">
             <a:avLst/>
@@ -2070,7 +2070,7 @@
         <p:spPr>
           <a:xfrm>
             <a:off x="11387160" y="10742760"/>
-            <a:ext cx="8708400" cy="561240"/>
+            <a:ext cx="8707320" cy="560160"/>
           </a:xfrm>
           <a:prstGeom prst="rect">
             <a:avLst/>
@@ -2112,7 +2112,7 @@
                 <a:tab algn="l" pos="0"/>
               </a:tabLst>
             </a:pPr>
-            <a:fld id="{8761ABF2-4425-415C-B168-40DD15A1AD4D}" type="slidenum">
+            <a:fld id="{07C1AFC1-D552-4A4D-AFED-F03A5847564C}" type="slidenum">
               <a:rPr b="0" lang="en-IN" sz="1200" spc="-1" strike="noStrike">
                 <a:solidFill>
                   <a:schemeClr val="dk1"/>
@@ -2166,7 +2166,7 @@
         <p:spPr>
           <a:xfrm>
             <a:off x="861120" y="2054160"/>
-            <a:ext cx="18728640" cy="1254600"/>
+            <a:ext cx="18727560" cy="1253520"/>
           </a:xfrm>
           <a:prstGeom prst="rect">
             <a:avLst/>
@@ -2206,7 +2206,7 @@
         <p:spPr>
           <a:xfrm>
             <a:off x="556560" y="4084560"/>
-            <a:ext cx="18728640" cy="7507080"/>
+            <a:ext cx="18727560" cy="7506000"/>
           </a:xfrm>
           <a:prstGeom prst="rect">
             <a:avLst/>
@@ -2250,7 +2250,7 @@
         <p:txBody>
           <a:bodyPr/>
           <a:p>
-            <a:fld id="{86BD86AA-5B2C-41B9-836B-0CF151AE845C}" type="slidenum">
+            <a:fld id="{1CDCC1F9-DFCF-4CF5-8623-EF95DB04604F}" type="slidenum">
               <a:t>&lt;#&gt;</a:t>
             </a:fld>
           </a:p>
@@ -2291,7 +2291,7 @@
         <p:spPr>
           <a:xfrm>
             <a:off x="861120" y="2054160"/>
-            <a:ext cx="18728640" cy="1254600"/>
+            <a:ext cx="18727560" cy="1253520"/>
           </a:xfrm>
           <a:prstGeom prst="rect">
             <a:avLst/>
@@ -2331,7 +2331,7 @@
         <p:spPr>
           <a:xfrm>
             <a:off x="556560" y="4084560"/>
-            <a:ext cx="18728640" cy="7507080"/>
+            <a:ext cx="18727560" cy="7506000"/>
           </a:xfrm>
           <a:prstGeom prst="rect">
             <a:avLst/>
@@ -2372,7 +2372,7 @@
         <p:txBody>
           <a:bodyPr/>
           <a:p>
-            <a:fld id="{B253499C-473C-4908-B2B9-C07FFEA29E55}" type="slidenum">
+            <a:fld id="{6257C536-5062-478C-9AD0-19F8E6247BF4}" type="slidenum">
               <a:t>&lt;#&gt;</a:t>
             </a:fld>
           </a:p>
@@ -2413,7 +2413,7 @@
         <p:spPr>
           <a:xfrm>
             <a:off x="861120" y="2054160"/>
-            <a:ext cx="18728640" cy="1254600"/>
+            <a:ext cx="18727560" cy="1253520"/>
           </a:xfrm>
           <a:prstGeom prst="rect">
             <a:avLst/>
@@ -2453,7 +2453,7 @@
         <p:spPr>
           <a:xfrm>
             <a:off x="556560" y="4084560"/>
-            <a:ext cx="18728640" cy="7507080"/>
+            <a:ext cx="18727560" cy="7506000"/>
           </a:xfrm>
           <a:prstGeom prst="rect">
             <a:avLst/>
@@ -2497,7 +2497,7 @@
         <p:txBody>
           <a:bodyPr/>
           <a:p>
-            <a:fld id="{01A63626-1526-477A-B269-80EADF74ADAB}" type="slidenum">
+            <a:fld id="{2ECA3A96-6CFD-4C36-B8A6-F3030E0919DE}" type="slidenum">
               <a:t>&lt;#&gt;</a:t>
             </a:fld>
           </a:p>
@@ -2538,7 +2538,7 @@
         <p:spPr>
           <a:xfrm>
             <a:off x="861120" y="2054160"/>
-            <a:ext cx="18728640" cy="1254600"/>
+            <a:ext cx="18727560" cy="1253520"/>
           </a:xfrm>
           <a:prstGeom prst="rect">
             <a:avLst/>
@@ -2578,7 +2578,7 @@
         <p:spPr>
           <a:xfrm>
             <a:off x="556560" y="4084560"/>
-            <a:ext cx="18728640" cy="7507080"/>
+            <a:ext cx="18727560" cy="7506000"/>
           </a:xfrm>
           <a:prstGeom prst="rect">
             <a:avLst/>
@@ -2622,7 +2622,7 @@
         <p:txBody>
           <a:bodyPr/>
           <a:p>
-            <a:fld id="{F5275774-2417-4C30-8948-8149C7501386}" type="slidenum">
+            <a:fld id="{61E538FF-6314-4259-BC6C-2E1256921AC9}" type="slidenum">
               <a:t>&lt;#&gt;</a:t>
             </a:fld>
           </a:p>
@@ -2663,7 +2663,7 @@
         <p:spPr>
           <a:xfrm>
             <a:off x="861120" y="2054160"/>
-            <a:ext cx="18728640" cy="1254600"/>
+            <a:ext cx="18727560" cy="1253520"/>
           </a:xfrm>
           <a:prstGeom prst="rect">
             <a:avLst/>
@@ -2703,7 +2703,7 @@
         <p:spPr>
           <a:xfrm>
             <a:off x="556560" y="4084560"/>
-            <a:ext cx="18728640" cy="7507080"/>
+            <a:ext cx="18727560" cy="7506000"/>
           </a:xfrm>
           <a:prstGeom prst="rect">
             <a:avLst/>
@@ -2747,7 +2747,7 @@
         <p:txBody>
           <a:bodyPr/>
           <a:p>
-            <a:fld id="{76C622C0-A6A1-4E6D-80F2-3D645BF71B80}" type="slidenum">
+            <a:fld id="{3536C9E9-DC59-4268-A65F-227117B62748}" type="slidenum">
               <a:t>&lt;#&gt;</a:t>
             </a:fld>
           </a:p>
@@ -2788,7 +2788,7 @@
         <p:spPr>
           <a:xfrm>
             <a:off x="861120" y="2054160"/>
-            <a:ext cx="18728640" cy="1254600"/>
+            <a:ext cx="18727560" cy="1253520"/>
           </a:xfrm>
           <a:prstGeom prst="rect">
             <a:avLst/>
@@ -2828,7 +2828,7 @@
         <p:spPr>
           <a:xfrm>
             <a:off x="556560" y="4084560"/>
-            <a:ext cx="18728640" cy="7507080"/>
+            <a:ext cx="18727560" cy="7506000"/>
           </a:xfrm>
           <a:prstGeom prst="rect">
             <a:avLst/>
@@ -2872,7 +2872,7 @@
         <p:txBody>
           <a:bodyPr/>
           <a:p>
-            <a:fld id="{33B369D8-EFD3-4CF2-AA6C-93B264BF86B0}" type="slidenum">
+            <a:fld id="{17E4765E-E8B2-47C2-85BF-2160943BCE80}" type="slidenum">
               <a:t>&lt;#&gt;</a:t>
             </a:fld>
           </a:p>
@@ -2913,7 +2913,7 @@
         <p:spPr>
           <a:xfrm>
             <a:off x="861120" y="2054160"/>
-            <a:ext cx="18728640" cy="1254600"/>
+            <a:ext cx="18727560" cy="1253520"/>
           </a:xfrm>
           <a:prstGeom prst="rect">
             <a:avLst/>
@@ -2953,7 +2953,7 @@
         <p:spPr>
           <a:xfrm>
             <a:off x="556560" y="4084560"/>
-            <a:ext cx="18728640" cy="7507080"/>
+            <a:ext cx="18727560" cy="7506000"/>
           </a:xfrm>
           <a:prstGeom prst="rect">
             <a:avLst/>
@@ -2997,7 +2997,7 @@
         <p:txBody>
           <a:bodyPr/>
           <a:p>
-            <a:fld id="{43947A7C-C2AB-449C-8D1D-4C54FE231A20}" type="slidenum">
+            <a:fld id="{37924475-AA1D-442B-8EBB-202EE5DDD44E}" type="slidenum">
               <a:t>&lt;#&gt;</a:t>
             </a:fld>
           </a:p>
@@ -3046,7 +3046,7 @@
         <p:spPr>
           <a:xfrm>
             <a:off x="474840" y="474840"/>
-            <a:ext cx="3310200" cy="1420200"/>
+            <a:ext cx="3309120" cy="1419120"/>
           </a:xfrm>
           <a:prstGeom prst="rect">
             <a:avLst/>
@@ -3069,7 +3069,7 @@
         <p:spPr>
           <a:xfrm>
             <a:off x="7614360" y="10400400"/>
-            <a:ext cx="4870800" cy="736920"/>
+            <a:ext cx="4869720" cy="735840"/>
           </a:xfrm>
           <a:prstGeom prst="rect">
             <a:avLst/>
@@ -3088,15 +3088,15 @@
         <p:spPr>
           <a:xfrm>
             <a:off x="2982960" y="712800"/>
-            <a:ext cx="53280" cy="53280"/>
+            <a:ext cx="52200" cy="52200"/>
           </a:xfrm>
           <a:custGeom>
             <a:avLst/>
             <a:gdLst>
-              <a:gd name="textAreaLeft" fmla="*/ 0 w 53280"/>
-              <a:gd name="textAreaRight" fmla="*/ 57240 w 53280"/>
-              <a:gd name="textAreaTop" fmla="*/ 0 h 53280"/>
-              <a:gd name="textAreaBottom" fmla="*/ 57240 h 53280"/>
+              <a:gd name="textAreaLeft" fmla="*/ 0 w 52200"/>
+              <a:gd name="textAreaRight" fmla="*/ 57240 w 52200"/>
+              <a:gd name="textAreaTop" fmla="*/ 0 h 52200"/>
+              <a:gd name="textAreaBottom" fmla="*/ 57240 h 52200"/>
             </a:gdLst>
             <a:ahLst/>
             <a:rect l="textAreaLeft" t="textAreaTop" r="textAreaRight" b="textAreaBottom"/>
@@ -3271,15 +3271,15 @@
         <p:spPr>
           <a:xfrm>
             <a:off x="2998800" y="725400"/>
-            <a:ext cx="21600" cy="27720"/>
+            <a:ext cx="20520" cy="26640"/>
           </a:xfrm>
           <a:custGeom>
             <a:avLst/>
             <a:gdLst>
-              <a:gd name="textAreaLeft" fmla="*/ 0 w 21600"/>
-              <a:gd name="textAreaRight" fmla="*/ 25560 w 21600"/>
-              <a:gd name="textAreaTop" fmla="*/ 0 h 27720"/>
-              <a:gd name="textAreaBottom" fmla="*/ 31680 h 27720"/>
+              <a:gd name="textAreaLeft" fmla="*/ 0 w 20520"/>
+              <a:gd name="textAreaRight" fmla="*/ 25560 w 20520"/>
+              <a:gd name="textAreaTop" fmla="*/ 0 h 26640"/>
+              <a:gd name="textAreaBottom" fmla="*/ 31680 h 26640"/>
             </a:gdLst>
             <a:ahLst/>
             <a:rect l="textAreaLeft" t="textAreaTop" r="textAreaRight" b="textAreaBottom"/>
@@ -3449,7 +3449,7 @@
         <p:spPr>
           <a:xfrm>
             <a:off x="861120" y="2054160"/>
-            <a:ext cx="18728640" cy="1254600"/>
+            <a:ext cx="18727560" cy="1253520"/>
           </a:xfrm>
           <a:prstGeom prst="rect">
             <a:avLst/>
@@ -3474,7 +3474,25 @@
                 </a:solidFill>
                 <a:latin typeface="Arial"/>
               </a:rPr>
-              <a:t>Click to edit the title text format</a:t>
+              <a:t>Click to edit </a:t>
+            </a:r>
+            <a:r>
+              <a:rPr b="0" lang="en-US" sz="1800" spc="-1" strike="noStrike">
+                <a:solidFill>
+                  <a:srgbClr val="000000"/>
+                </a:solidFill>
+                <a:latin typeface="Arial"/>
+              </a:rPr>
+              <a:t>the title text </a:t>
+            </a:r>
+            <a:r>
+              <a:rPr b="0" lang="en-US" sz="1800" spc="-1" strike="noStrike">
+                <a:solidFill>
+                  <a:srgbClr val="000000"/>
+                </a:solidFill>
+                <a:latin typeface="Arial"/>
+              </a:rPr>
+              <a:t>format</a:t>
             </a:r>
             <a:endParaRPr b="0" lang="en-US" sz="1800" spc="-1" strike="noStrike">
               <a:solidFill>
@@ -3498,7 +3516,7 @@
         <p:spPr>
           <a:xfrm>
             <a:off x="556560" y="4084560"/>
-            <a:ext cx="18728640" cy="7507080"/>
+            <a:ext cx="18727560" cy="7506000"/>
           </a:xfrm>
           <a:prstGeom prst="rect">
             <a:avLst/>
@@ -3723,7 +3741,7 @@
         <p:spPr>
           <a:xfrm>
             <a:off x="18627840" y="10253160"/>
-            <a:ext cx="1201320" cy="860400"/>
+            <a:ext cx="1200240" cy="859320"/>
           </a:xfrm>
           <a:prstGeom prst="rect">
             <a:avLst/>
@@ -3765,7 +3783,7 @@
                 <a:tab algn="l" pos="0"/>
               </a:tabLst>
             </a:pPr>
-            <a:fld id="{B058A21F-DB21-41A7-B042-F81FAA5C17A4}" type="slidenum">
+            <a:fld id="{EB6A60B8-7B86-44B2-917C-EF9CCDE76F7F}" type="slidenum">
               <a:rPr b="0" lang="en-IN" sz="2200" spc="-1" strike="noStrike">
                 <a:solidFill>
                   <a:schemeClr val="dk2"/>
@@ -3831,7 +3849,7 @@
         <p:spPr>
           <a:xfrm>
             <a:off x="474840" y="474840"/>
-            <a:ext cx="3310200" cy="1420200"/>
+            <a:ext cx="3309120" cy="1419120"/>
           </a:xfrm>
           <a:prstGeom prst="rect">
             <a:avLst/>
@@ -3854,7 +3872,7 @@
         <p:spPr>
           <a:xfrm>
             <a:off x="7614360" y="10400400"/>
-            <a:ext cx="4870800" cy="736920"/>
+            <a:ext cx="4869720" cy="735840"/>
           </a:xfrm>
           <a:prstGeom prst="rect">
             <a:avLst/>
@@ -3873,15 +3891,15 @@
         <p:spPr>
           <a:xfrm>
             <a:off x="2982960" y="712800"/>
-            <a:ext cx="53280" cy="53280"/>
+            <a:ext cx="52200" cy="52200"/>
           </a:xfrm>
           <a:custGeom>
             <a:avLst/>
             <a:gdLst>
-              <a:gd name="textAreaLeft" fmla="*/ 0 w 53280"/>
-              <a:gd name="textAreaRight" fmla="*/ 57240 w 53280"/>
-              <a:gd name="textAreaTop" fmla="*/ 0 h 53280"/>
-              <a:gd name="textAreaBottom" fmla="*/ 57240 h 53280"/>
+              <a:gd name="textAreaLeft" fmla="*/ 0 w 52200"/>
+              <a:gd name="textAreaRight" fmla="*/ 57240 w 52200"/>
+              <a:gd name="textAreaTop" fmla="*/ 0 h 52200"/>
+              <a:gd name="textAreaBottom" fmla="*/ 57240 h 52200"/>
             </a:gdLst>
             <a:ahLst/>
             <a:rect l="textAreaLeft" t="textAreaTop" r="textAreaRight" b="textAreaBottom"/>
@@ -4056,15 +4074,15 @@
         <p:spPr>
           <a:xfrm>
             <a:off x="2998800" y="725400"/>
-            <a:ext cx="21600" cy="27720"/>
+            <a:ext cx="20520" cy="26640"/>
           </a:xfrm>
           <a:custGeom>
             <a:avLst/>
             <a:gdLst>
-              <a:gd name="textAreaLeft" fmla="*/ 0 w 21600"/>
-              <a:gd name="textAreaRight" fmla="*/ 25560 w 21600"/>
-              <a:gd name="textAreaTop" fmla="*/ 0 h 27720"/>
-              <a:gd name="textAreaBottom" fmla="*/ 31680 h 27720"/>
+              <a:gd name="textAreaLeft" fmla="*/ 0 w 20520"/>
+              <a:gd name="textAreaRight" fmla="*/ 25560 w 20520"/>
+              <a:gd name="textAreaTop" fmla="*/ 0 h 26640"/>
+              <a:gd name="textAreaBottom" fmla="*/ 31680 h 26640"/>
             </a:gdLst>
             <a:ahLst/>
             <a:rect l="textAreaLeft" t="textAreaTop" r="textAreaRight" b="textAreaBottom"/>
@@ -4234,7 +4252,7 @@
         <p:spPr>
           <a:xfrm>
             <a:off x="861120" y="2054160"/>
-            <a:ext cx="18728640" cy="1254600"/>
+            <a:ext cx="18727560" cy="1253520"/>
           </a:xfrm>
           <a:prstGeom prst="rect">
             <a:avLst/>
@@ -4259,7 +4277,25 @@
                 </a:solidFill>
                 <a:latin typeface="Arial"/>
               </a:rPr>
-              <a:t>Click to edit the title text format</a:t>
+              <a:t>Click to edit </a:t>
+            </a:r>
+            <a:r>
+              <a:rPr b="0" lang="en-US" sz="1800" spc="-1" strike="noStrike">
+                <a:solidFill>
+                  <a:srgbClr val="000000"/>
+                </a:solidFill>
+                <a:latin typeface="Arial"/>
+              </a:rPr>
+              <a:t>the title text </a:t>
+            </a:r>
+            <a:r>
+              <a:rPr b="0" lang="en-US" sz="1800" spc="-1" strike="noStrike">
+                <a:solidFill>
+                  <a:srgbClr val="000000"/>
+                </a:solidFill>
+                <a:latin typeface="Arial"/>
+              </a:rPr>
+              <a:t>format</a:t>
             </a:r>
             <a:endParaRPr b="0" lang="en-US" sz="1800" spc="-1" strike="noStrike">
               <a:solidFill>
@@ -4283,7 +4319,7 @@
         <p:spPr>
           <a:xfrm>
             <a:off x="18627840" y="10253160"/>
-            <a:ext cx="1201320" cy="860400"/>
+            <a:ext cx="1200240" cy="859320"/>
           </a:xfrm>
           <a:prstGeom prst="rect">
             <a:avLst/>
@@ -4325,7 +4361,7 @@
                 <a:tab algn="l" pos="0"/>
               </a:tabLst>
             </a:pPr>
-            <a:fld id="{2E375D0F-F83C-40B0-9597-400D8614BE05}" type="slidenum">
+            <a:fld id="{FE800FAA-0969-402A-A51F-5D34F488A69B}" type="slidenum">
               <a:rPr b="0" lang="en-IN" sz="2200" spc="-1" strike="noStrike">
                 <a:solidFill>
                   <a:schemeClr val="dk2"/>
@@ -4616,7 +4652,7 @@
         <p:spPr>
           <a:xfrm>
             <a:off x="474840" y="474840"/>
-            <a:ext cx="3310200" cy="1420200"/>
+            <a:ext cx="3309120" cy="1419120"/>
           </a:xfrm>
           <a:prstGeom prst="rect">
             <a:avLst/>
@@ -4639,7 +4675,7 @@
         <p:spPr>
           <a:xfrm>
             <a:off x="15354360" y="912600"/>
-            <a:ext cx="4335120" cy="655560"/>
+            <a:ext cx="4334040" cy="654480"/>
           </a:xfrm>
           <a:prstGeom prst="rect">
             <a:avLst/>
@@ -4662,7 +4698,7 @@
         <p:spPr>
           <a:xfrm>
             <a:off x="861120" y="2054160"/>
-            <a:ext cx="18728640" cy="1254600"/>
+            <a:ext cx="18727560" cy="1253520"/>
           </a:xfrm>
           <a:prstGeom prst="rect">
             <a:avLst/>
@@ -4687,7 +4723,25 @@
                 </a:solidFill>
                 <a:latin typeface="Arial"/>
               </a:rPr>
-              <a:t>Click to edit the title text format</a:t>
+              <a:t>Click to edit </a:t>
+            </a:r>
+            <a:r>
+              <a:rPr b="0" lang="en-US" sz="1800" spc="-1" strike="noStrike">
+                <a:solidFill>
+                  <a:srgbClr val="000000"/>
+                </a:solidFill>
+                <a:latin typeface="Arial"/>
+              </a:rPr>
+              <a:t>the title text </a:t>
+            </a:r>
+            <a:r>
+              <a:rPr b="0" lang="en-US" sz="1800" spc="-1" strike="noStrike">
+                <a:solidFill>
+                  <a:srgbClr val="000000"/>
+                </a:solidFill>
+                <a:latin typeface="Arial"/>
+              </a:rPr>
+              <a:t>format</a:t>
             </a:r>
             <a:endParaRPr b="0" lang="en-US" sz="1800" spc="-1" strike="noStrike">
               <a:solidFill>
@@ -4711,7 +4765,7 @@
         <p:spPr>
           <a:xfrm>
             <a:off x="556560" y="4084560"/>
-            <a:ext cx="18728640" cy="7507080"/>
+            <a:ext cx="18727560" cy="7506000"/>
           </a:xfrm>
           <a:prstGeom prst="rect">
             <a:avLst/>
@@ -4936,7 +4990,7 @@
         <p:spPr>
           <a:xfrm>
             <a:off x="18627840" y="10253160"/>
-            <a:ext cx="1201320" cy="860400"/>
+            <a:ext cx="1200240" cy="859320"/>
           </a:xfrm>
           <a:prstGeom prst="rect">
             <a:avLst/>
@@ -4978,7 +5032,7 @@
                 <a:tab algn="l" pos="0"/>
               </a:tabLst>
             </a:pPr>
-            <a:fld id="{741F490B-A0D5-4320-8C3D-54EC8372B710}" type="slidenum">
+            <a:fld id="{8546844D-FC60-4E16-BAAA-A89CABEF948E}" type="slidenum">
               <a:rPr b="0" lang="en-IN" sz="2200" spc="-1" strike="noStrike">
                 <a:solidFill>
                   <a:schemeClr val="dk2"/>
@@ -5044,7 +5098,7 @@
         <p:spPr>
           <a:xfrm>
             <a:off x="474840" y="474840"/>
-            <a:ext cx="3310200" cy="1420200"/>
+            <a:ext cx="3309120" cy="1419120"/>
           </a:xfrm>
           <a:prstGeom prst="rect">
             <a:avLst/>
@@ -5067,7 +5121,7 @@
         <p:spPr>
           <a:xfrm>
             <a:off x="15354360" y="912600"/>
-            <a:ext cx="4335120" cy="655560"/>
+            <a:ext cx="4334040" cy="654480"/>
           </a:xfrm>
           <a:prstGeom prst="rect">
             <a:avLst/>
@@ -5090,7 +5144,7 @@
         <p:spPr>
           <a:xfrm>
             <a:off x="861120" y="2054160"/>
-            <a:ext cx="18728640" cy="1254600"/>
+            <a:ext cx="18727560" cy="1253520"/>
           </a:xfrm>
           <a:prstGeom prst="rect">
             <a:avLst/>
@@ -5115,7 +5169,25 @@
                 </a:solidFill>
                 <a:latin typeface="Arial"/>
               </a:rPr>
-              <a:t>Click to edit the title text format</a:t>
+              <a:t>Click to edit </a:t>
+            </a:r>
+            <a:r>
+              <a:rPr b="0" lang="en-US" sz="1800" spc="-1" strike="noStrike">
+                <a:solidFill>
+                  <a:srgbClr val="000000"/>
+                </a:solidFill>
+                <a:latin typeface="Arial"/>
+              </a:rPr>
+              <a:t>the title text </a:t>
+            </a:r>
+            <a:r>
+              <a:rPr b="0" lang="en-US" sz="1800" spc="-1" strike="noStrike">
+                <a:solidFill>
+                  <a:srgbClr val="000000"/>
+                </a:solidFill>
+                <a:latin typeface="Arial"/>
+              </a:rPr>
+              <a:t>format</a:t>
             </a:r>
             <a:endParaRPr b="0" lang="en-US" sz="1800" spc="-1" strike="noStrike">
               <a:solidFill>
@@ -5139,7 +5211,7 @@
         <p:spPr>
           <a:xfrm>
             <a:off x="556560" y="4084560"/>
-            <a:ext cx="18728640" cy="7507080"/>
+            <a:ext cx="18727560" cy="7506000"/>
           </a:xfrm>
           <a:prstGeom prst="rect">
             <a:avLst/>
@@ -5364,7 +5436,7 @@
         <p:spPr>
           <a:xfrm>
             <a:off x="18627840" y="10253160"/>
-            <a:ext cx="1201320" cy="860400"/>
+            <a:ext cx="1200240" cy="859320"/>
           </a:xfrm>
           <a:prstGeom prst="rect">
             <a:avLst/>
@@ -5406,7 +5478,7 @@
                 <a:tab algn="l" pos="0"/>
               </a:tabLst>
             </a:pPr>
-            <a:fld id="{E52A926B-6C76-499D-B285-7BC69AF8829A}" type="slidenum">
+            <a:fld id="{4AF07BE0-FD9E-4C74-8B6D-D7EF018BFA5B}" type="slidenum">
               <a:rPr b="0" lang="en-IN" sz="2200" spc="-1" strike="noStrike">
                 <a:solidFill>
                   <a:schemeClr val="dk2"/>
@@ -5472,7 +5544,7 @@
         <p:spPr>
           <a:xfrm>
             <a:off x="474840" y="474840"/>
-            <a:ext cx="3310200" cy="1420200"/>
+            <a:ext cx="3309120" cy="1419120"/>
           </a:xfrm>
           <a:prstGeom prst="rect">
             <a:avLst/>
@@ -5495,7 +5567,7 @@
         <p:spPr>
           <a:xfrm>
             <a:off x="15354360" y="912600"/>
-            <a:ext cx="4335120" cy="655560"/>
+            <a:ext cx="4334040" cy="654480"/>
           </a:xfrm>
           <a:prstGeom prst="rect">
             <a:avLst/>
@@ -5518,7 +5590,7 @@
         <p:spPr>
           <a:xfrm>
             <a:off x="861120" y="2054160"/>
-            <a:ext cx="18728640" cy="1254600"/>
+            <a:ext cx="18727560" cy="1253520"/>
           </a:xfrm>
           <a:prstGeom prst="rect">
             <a:avLst/>
@@ -5543,7 +5615,25 @@
                 </a:solidFill>
                 <a:latin typeface="Arial"/>
               </a:rPr>
-              <a:t>Click to edit the title text format</a:t>
+              <a:t>Click to edit </a:t>
+            </a:r>
+            <a:r>
+              <a:rPr b="0" lang="en-US" sz="1800" spc="-1" strike="noStrike">
+                <a:solidFill>
+                  <a:srgbClr val="000000"/>
+                </a:solidFill>
+                <a:latin typeface="Arial"/>
+              </a:rPr>
+              <a:t>the title text </a:t>
+            </a:r>
+            <a:r>
+              <a:rPr b="0" lang="en-US" sz="1800" spc="-1" strike="noStrike">
+                <a:solidFill>
+                  <a:srgbClr val="000000"/>
+                </a:solidFill>
+                <a:latin typeface="Arial"/>
+              </a:rPr>
+              <a:t>format</a:t>
             </a:r>
             <a:endParaRPr b="0" lang="en-US" sz="1800" spc="-1" strike="noStrike">
               <a:solidFill>
@@ -5567,7 +5657,7 @@
         <p:spPr>
           <a:xfrm>
             <a:off x="556560" y="4084560"/>
-            <a:ext cx="18728640" cy="7507080"/>
+            <a:ext cx="18727560" cy="7506000"/>
           </a:xfrm>
           <a:prstGeom prst="rect">
             <a:avLst/>
@@ -5792,7 +5882,7 @@
         <p:spPr>
           <a:xfrm>
             <a:off x="18627840" y="10253160"/>
-            <a:ext cx="1201320" cy="860400"/>
+            <a:ext cx="1200240" cy="859320"/>
           </a:xfrm>
           <a:prstGeom prst="rect">
             <a:avLst/>
@@ -5834,7 +5924,7 @@
                 <a:tab algn="l" pos="0"/>
               </a:tabLst>
             </a:pPr>
-            <a:fld id="{38ACF37C-43FF-4E9A-9B32-8FA23B60DD38}" type="slidenum">
+            <a:fld id="{FD3EBBBB-0280-4E83-B9B8-8C042FC23344}" type="slidenum">
               <a:rPr b="0" lang="en-IN" sz="2200" spc="-1" strike="noStrike">
                 <a:solidFill>
                   <a:schemeClr val="dk2"/>
@@ -5900,7 +5990,7 @@
         <p:spPr>
           <a:xfrm>
             <a:off x="474840" y="474840"/>
-            <a:ext cx="3310200" cy="1420200"/>
+            <a:ext cx="3309120" cy="1419120"/>
           </a:xfrm>
           <a:prstGeom prst="rect">
             <a:avLst/>
@@ -5923,7 +6013,7 @@
         <p:spPr>
           <a:xfrm>
             <a:off x="15354360" y="912600"/>
-            <a:ext cx="4335120" cy="655560"/>
+            <a:ext cx="4334040" cy="654480"/>
           </a:xfrm>
           <a:prstGeom prst="rect">
             <a:avLst/>
@@ -5946,7 +6036,7 @@
         <p:spPr>
           <a:xfrm>
             <a:off x="861120" y="2054160"/>
-            <a:ext cx="18728640" cy="1254600"/>
+            <a:ext cx="18727560" cy="1253520"/>
           </a:xfrm>
           <a:prstGeom prst="rect">
             <a:avLst/>
@@ -5971,7 +6061,25 @@
                 </a:solidFill>
                 <a:latin typeface="Arial"/>
               </a:rPr>
-              <a:t>Click to edit the title text format</a:t>
+              <a:t>Click to edit </a:t>
+            </a:r>
+            <a:r>
+              <a:rPr b="0" lang="en-US" sz="1800" spc="-1" strike="noStrike">
+                <a:solidFill>
+                  <a:srgbClr val="000000"/>
+                </a:solidFill>
+                <a:latin typeface="Arial"/>
+              </a:rPr>
+              <a:t>the title text </a:t>
+            </a:r>
+            <a:r>
+              <a:rPr b="0" lang="en-US" sz="1800" spc="-1" strike="noStrike">
+                <a:solidFill>
+                  <a:srgbClr val="000000"/>
+                </a:solidFill>
+                <a:latin typeface="Arial"/>
+              </a:rPr>
+              <a:t>format</a:t>
             </a:r>
             <a:endParaRPr b="0" lang="en-US" sz="1800" spc="-1" strike="noStrike">
               <a:solidFill>
@@ -5995,7 +6103,7 @@
         <p:spPr>
           <a:xfrm>
             <a:off x="556560" y="4084560"/>
-            <a:ext cx="18728640" cy="7507080"/>
+            <a:ext cx="18727560" cy="7506000"/>
           </a:xfrm>
           <a:prstGeom prst="rect">
             <a:avLst/>
@@ -6220,7 +6328,7 @@
         <p:spPr>
           <a:xfrm>
             <a:off x="18627840" y="10253160"/>
-            <a:ext cx="1201320" cy="860400"/>
+            <a:ext cx="1200240" cy="859320"/>
           </a:xfrm>
           <a:prstGeom prst="rect">
             <a:avLst/>
@@ -6262,7 +6370,7 @@
                 <a:tab algn="l" pos="0"/>
               </a:tabLst>
             </a:pPr>
-            <a:fld id="{B3F0297E-EB39-46FD-98B9-FF8CA757742D}" type="slidenum">
+            <a:fld id="{8592F63A-A4BB-43E6-9263-2BC76EB0C82D}" type="slidenum">
               <a:rPr b="0" lang="en-IN" sz="2200" spc="-1" strike="noStrike">
                 <a:solidFill>
                   <a:schemeClr val="dk2"/>
@@ -6328,7 +6436,7 @@
         <p:spPr>
           <a:xfrm>
             <a:off x="474840" y="474840"/>
-            <a:ext cx="3310200" cy="1420200"/>
+            <a:ext cx="3309120" cy="1419120"/>
           </a:xfrm>
           <a:prstGeom prst="rect">
             <a:avLst/>
@@ -6351,7 +6459,7 @@
         <p:spPr>
           <a:xfrm>
             <a:off x="15354360" y="912600"/>
-            <a:ext cx="4335120" cy="655560"/>
+            <a:ext cx="4334040" cy="654480"/>
           </a:xfrm>
           <a:prstGeom prst="rect">
             <a:avLst/>
@@ -6374,7 +6482,7 @@
         <p:spPr>
           <a:xfrm>
             <a:off x="861120" y="2054160"/>
-            <a:ext cx="18728640" cy="1254600"/>
+            <a:ext cx="18727560" cy="1253520"/>
           </a:xfrm>
           <a:prstGeom prst="rect">
             <a:avLst/>
@@ -6399,25 +6507,7 @@
                 </a:solidFill>
                 <a:latin typeface="Arial"/>
               </a:rPr>
-              <a:t>Click to edit </a:t>
-            </a:r>
-            <a:r>
-              <a:rPr b="0" lang="en-US" sz="1800" spc="-1" strike="noStrike">
-                <a:solidFill>
-                  <a:srgbClr val="000000"/>
-                </a:solidFill>
-                <a:latin typeface="Arial"/>
-              </a:rPr>
-              <a:t>the title text </a:t>
-            </a:r>
-            <a:r>
-              <a:rPr b="0" lang="en-US" sz="1800" spc="-1" strike="noStrike">
-                <a:solidFill>
-                  <a:srgbClr val="000000"/>
-                </a:solidFill>
-                <a:latin typeface="Arial"/>
-              </a:rPr>
-              <a:t>format</a:t>
+              <a:t>Click to edit the title text format</a:t>
             </a:r>
             <a:endParaRPr b="0" lang="en-US" sz="1800" spc="-1" strike="noStrike">
               <a:solidFill>
@@ -6441,7 +6531,7 @@
         <p:spPr>
           <a:xfrm>
             <a:off x="556560" y="4084560"/>
-            <a:ext cx="18728640" cy="7507080"/>
+            <a:ext cx="18727560" cy="7506000"/>
           </a:xfrm>
           <a:prstGeom prst="rect">
             <a:avLst/>
@@ -6666,7 +6756,7 @@
         <p:spPr>
           <a:xfrm>
             <a:off x="18627840" y="10253160"/>
-            <a:ext cx="1201320" cy="860400"/>
+            <a:ext cx="1200240" cy="859320"/>
           </a:xfrm>
           <a:prstGeom prst="rect">
             <a:avLst/>
@@ -6708,7 +6798,7 @@
                 <a:tab algn="l" pos="0"/>
               </a:tabLst>
             </a:pPr>
-            <a:fld id="{5F265B62-1847-4D04-A2F0-8EBA17CFEA36}" type="slidenum">
+            <a:fld id="{661D5638-9F50-4D57-B071-30A8AB99147A}" type="slidenum">
               <a:rPr b="0" lang="en-IN" sz="2200" spc="-1" strike="noStrike">
                 <a:solidFill>
                   <a:schemeClr val="dk2"/>
@@ -6762,7 +6852,7 @@
         <p:spPr>
           <a:xfrm>
             <a:off x="4443840" y="2008080"/>
-            <a:ext cx="11212920" cy="1391400"/>
+            <a:ext cx="11211840" cy="1390320"/>
           </a:xfrm>
           <a:prstGeom prst="rect">
             <a:avLst/>
@@ -6819,7 +6909,7 @@
         <p:spPr>
           <a:xfrm>
             <a:off x="1575360" y="3254400"/>
-            <a:ext cx="17013240" cy="6955560"/>
+            <a:ext cx="17012160" cy="6954480"/>
           </a:xfrm>
           <a:prstGeom prst="rect">
             <a:avLst/>
@@ -7040,7 +7130,7 @@
         <p:spPr>
           <a:xfrm>
             <a:off x="18627840" y="10253160"/>
-            <a:ext cx="1201320" cy="860400"/>
+            <a:ext cx="1200240" cy="859320"/>
           </a:xfrm>
           <a:prstGeom prst="rect">
             <a:avLst/>
@@ -7082,7 +7172,7 @@
                 <a:tab algn="l" pos="0"/>
               </a:tabLst>
             </a:pPr>
-            <a:fld id="{9E5AAD3C-6B4C-4342-89F6-40A10E4BD0D8}" type="slidenum">
+            <a:fld id="{CF7BE293-99B3-48DF-8100-31F0EFB83668}" type="slidenum">
               <a:rPr b="0" lang="en-IN" sz="2200" spc="-1" strike="noStrike">
                 <a:solidFill>
                   <a:schemeClr val="dk2"/>
@@ -7110,7 +7200,7 @@
         <p:spPr>
           <a:xfrm>
             <a:off x="4599360" y="351000"/>
-            <a:ext cx="10901520" cy="1391400"/>
+            <a:ext cx="10900440" cy="1390320"/>
           </a:xfrm>
           <a:prstGeom prst="rect">
             <a:avLst/>
@@ -7167,7 +7257,7 @@
         <p:spPr>
           <a:xfrm>
             <a:off x="7315200" y="8124840"/>
-            <a:ext cx="5501880" cy="3183840"/>
+            <a:ext cx="5500800" cy="3182760"/>
           </a:xfrm>
           <a:prstGeom prst="rect">
             <a:avLst/>
@@ -7251,15 +7341,15 @@
         <p:spPr>
           <a:xfrm>
             <a:off x="2982960" y="712800"/>
-            <a:ext cx="53280" cy="53280"/>
+            <a:ext cx="52200" cy="52200"/>
           </a:xfrm>
           <a:custGeom>
             <a:avLst/>
             <a:gdLst>
-              <a:gd name="textAreaLeft" fmla="*/ 0 w 53280"/>
-              <a:gd name="textAreaRight" fmla="*/ 57240 w 53280"/>
-              <a:gd name="textAreaTop" fmla="*/ 0 h 53280"/>
-              <a:gd name="textAreaBottom" fmla="*/ 57240 h 53280"/>
+              <a:gd name="textAreaLeft" fmla="*/ 0 w 52200"/>
+              <a:gd name="textAreaRight" fmla="*/ 57240 w 52200"/>
+              <a:gd name="textAreaTop" fmla="*/ 0 h 52200"/>
+              <a:gd name="textAreaBottom" fmla="*/ 57240 h 52200"/>
             </a:gdLst>
             <a:ahLst/>
             <a:rect l="textAreaLeft" t="textAreaTop" r="textAreaRight" b="textAreaBottom"/>
@@ -7434,15 +7524,15 @@
         <p:spPr>
           <a:xfrm>
             <a:off x="2998800" y="725400"/>
-            <a:ext cx="21600" cy="27720"/>
+            <a:ext cx="20520" cy="26640"/>
           </a:xfrm>
           <a:custGeom>
             <a:avLst/>
             <a:gdLst>
-              <a:gd name="textAreaLeft" fmla="*/ 0 w 21600"/>
-              <a:gd name="textAreaRight" fmla="*/ 25560 w 21600"/>
-              <a:gd name="textAreaTop" fmla="*/ 0 h 27720"/>
-              <a:gd name="textAreaBottom" fmla="*/ 31680 h 27720"/>
+              <a:gd name="textAreaLeft" fmla="*/ 0 w 20520"/>
+              <a:gd name="textAreaRight" fmla="*/ 25560 w 20520"/>
+              <a:gd name="textAreaTop" fmla="*/ 0 h 26640"/>
+              <a:gd name="textAreaBottom" fmla="*/ 31680 h 26640"/>
             </a:gdLst>
             <a:ahLst/>
             <a:rect l="textAreaLeft" t="textAreaTop" r="textAreaRight" b="textAreaBottom"/>
@@ -7612,7 +7702,7 @@
         <p:spPr>
           <a:xfrm>
             <a:off x="18627840" y="10253160"/>
-            <a:ext cx="1201320" cy="860400"/>
+            <a:ext cx="1200240" cy="859320"/>
           </a:xfrm>
           <a:prstGeom prst="rect">
             <a:avLst/>
@@ -7654,7 +7744,7 @@
                 <a:tab algn="l" pos="0"/>
               </a:tabLst>
             </a:pPr>
-            <a:fld id="{EE26C95E-8333-4BDE-9FAF-3CB1C0E0C38D}" type="slidenum">
+            <a:fld id="{314F4A0B-0592-46BB-BAD9-867FC515CDC1}" type="slidenum">
               <a:rPr b="0" lang="en-IN" sz="2200" spc="-1" strike="noStrike">
                 <a:solidFill>
                   <a:schemeClr val="dk2"/>
@@ -7682,7 +7772,7 @@
         <p:spPr>
           <a:xfrm>
             <a:off x="5057640" y="290520"/>
-            <a:ext cx="9066960" cy="635760"/>
+            <a:ext cx="9065880" cy="634680"/>
           </a:xfrm>
           <a:prstGeom prst="rect">
             <a:avLst/>
@@ -7739,7 +7829,7 @@
         <p:spPr>
           <a:xfrm>
             <a:off x="7086600" y="10094400"/>
-            <a:ext cx="5027400" cy="1213200"/>
+            <a:ext cx="5026320" cy="1212120"/>
           </a:xfrm>
           <a:prstGeom prst="rect">
             <a:avLst/>
@@ -7797,7 +7887,7 @@
         <p:spPr>
           <a:xfrm>
             <a:off x="6333120" y="1828800"/>
-            <a:ext cx="6927840" cy="7542720"/>
+            <a:ext cx="6926760" cy="7541640"/>
           </a:xfrm>
           <a:prstGeom prst="rect">
             <a:avLst/>
@@ -7850,7 +7940,7 @@
         <p:spPr>
           <a:xfrm>
             <a:off x="4800600" y="2057400"/>
-            <a:ext cx="10056600" cy="7656840"/>
+            <a:ext cx="10055520" cy="7655760"/>
           </a:xfrm>
           <a:prstGeom prst="rect">
             <a:avLst/>
@@ -7869,7 +7959,7 @@
         <p:spPr>
           <a:xfrm>
             <a:off x="8015400" y="10287000"/>
-            <a:ext cx="4557600" cy="914400"/>
+            <a:ext cx="4556520" cy="913320"/>
           </a:xfrm>
           <a:prstGeom prst="rect">
             <a:avLst/>
@@ -7923,7 +8013,7 @@
         <p:spPr>
           <a:xfrm>
             <a:off x="7543800" y="685800"/>
-            <a:ext cx="4572000" cy="707760"/>
+            <a:ext cx="4570920" cy="706680"/>
           </a:xfrm>
           <a:prstGeom prst="rect">
             <a:avLst/>
@@ -8011,7 +8101,7 @@
         <p:spPr>
           <a:xfrm>
             <a:off x="2632680" y="1324080"/>
-            <a:ext cx="13596120" cy="8732520"/>
+            <a:ext cx="13595040" cy="8731440"/>
           </a:xfrm>
           <a:prstGeom prst="rect">
             <a:avLst/>
@@ -8030,7 +8120,7 @@
         <p:spPr>
           <a:xfrm>
             <a:off x="7772400" y="10287000"/>
-            <a:ext cx="4343040" cy="651240"/>
+            <a:ext cx="4341960" cy="650160"/>
           </a:xfrm>
           <a:prstGeom prst="rect">
             <a:avLst/>
@@ -8114,7 +8204,7 @@
         <p:spPr>
           <a:xfrm>
             <a:off x="7772400" y="10092960"/>
-            <a:ext cx="3867120" cy="651240"/>
+            <a:ext cx="3866040" cy="650160"/>
           </a:xfrm>
           <a:prstGeom prst="rect">
             <a:avLst/>
@@ -8172,7 +8262,7 @@
         <p:spPr>
           <a:xfrm>
             <a:off x="5913360" y="2057400"/>
-            <a:ext cx="7802640" cy="7802640"/>
+            <a:ext cx="7801560" cy="7801560"/>
           </a:xfrm>
           <a:prstGeom prst="rect">
             <a:avLst/>
@@ -8221,7 +8311,7 @@
         <p:spPr>
           <a:xfrm>
             <a:off x="8160840" y="10272240"/>
-            <a:ext cx="4412160" cy="650880"/>
+            <a:ext cx="4411080" cy="649800"/>
           </a:xfrm>
           <a:prstGeom prst="rect">
             <a:avLst/>
@@ -8279,7 +8369,7 @@
         <p:spPr>
           <a:xfrm>
             <a:off x="4386960" y="1509120"/>
-            <a:ext cx="9786240" cy="8320680"/>
+            <a:ext cx="9785160" cy="8319600"/>
           </a:xfrm>
           <a:prstGeom prst="rect">
             <a:avLst/>
@@ -8328,15 +8418,15 @@
         <p:spPr>
           <a:xfrm>
             <a:off x="2982960" y="712800"/>
-            <a:ext cx="53280" cy="53280"/>
+            <a:ext cx="52200" cy="52200"/>
           </a:xfrm>
           <a:custGeom>
             <a:avLst/>
             <a:gdLst>
-              <a:gd name="textAreaLeft" fmla="*/ 0 w 53280"/>
-              <a:gd name="textAreaRight" fmla="*/ 57240 w 53280"/>
-              <a:gd name="textAreaTop" fmla="*/ 0 h 53280"/>
-              <a:gd name="textAreaBottom" fmla="*/ 57240 h 53280"/>
+              <a:gd name="textAreaLeft" fmla="*/ 0 w 52200"/>
+              <a:gd name="textAreaRight" fmla="*/ 57240 w 52200"/>
+              <a:gd name="textAreaTop" fmla="*/ 0 h 52200"/>
+              <a:gd name="textAreaBottom" fmla="*/ 57240 h 52200"/>
             </a:gdLst>
             <a:ahLst/>
             <a:rect l="textAreaLeft" t="textAreaTop" r="textAreaRight" b="textAreaBottom"/>
@@ -8511,15 +8601,15 @@
         <p:spPr>
           <a:xfrm>
             <a:off x="2998800" y="725400"/>
-            <a:ext cx="21600" cy="27720"/>
+            <a:ext cx="20520" cy="26640"/>
           </a:xfrm>
           <a:custGeom>
             <a:avLst/>
             <a:gdLst>
-              <a:gd name="textAreaLeft" fmla="*/ 0 w 21600"/>
-              <a:gd name="textAreaRight" fmla="*/ 25560 w 21600"/>
-              <a:gd name="textAreaTop" fmla="*/ 0 h 27720"/>
-              <a:gd name="textAreaBottom" fmla="*/ 31680 h 27720"/>
+              <a:gd name="textAreaLeft" fmla="*/ 0 w 20520"/>
+              <a:gd name="textAreaRight" fmla="*/ 25560 w 20520"/>
+              <a:gd name="textAreaTop" fmla="*/ 0 h 26640"/>
+              <a:gd name="textAreaBottom" fmla="*/ 31680 h 26640"/>
             </a:gdLst>
             <a:ahLst/>
             <a:rect l="textAreaLeft" t="textAreaTop" r="textAreaRight" b="textAreaBottom"/>
@@ -8689,7 +8779,7 @@
         <p:spPr>
           <a:xfrm>
             <a:off x="18627840" y="10253160"/>
-            <a:ext cx="1201320" cy="860400"/>
+            <a:ext cx="1200240" cy="859320"/>
           </a:xfrm>
           <a:prstGeom prst="rect">
             <a:avLst/>
@@ -8731,7 +8821,7 @@
                 <a:tab algn="l" pos="0"/>
               </a:tabLst>
             </a:pPr>
-            <a:fld id="{F2438794-E7AC-4FBB-ABE8-67DED4C739EC}" type="slidenum">
+            <a:fld id="{02FE205A-6B0F-4DFD-9F48-8351EB4389E0}" type="slidenum">
               <a:rPr b="0" lang="en-IN" sz="2200" spc="-1" strike="noStrike">
                 <a:solidFill>
                   <a:schemeClr val="dk2"/>
@@ -8759,7 +8849,7 @@
         <p:spPr>
           <a:xfrm>
             <a:off x="5057640" y="290520"/>
-            <a:ext cx="9067320" cy="636120"/>
+            <a:ext cx="9066240" cy="635040"/>
           </a:xfrm>
           <a:prstGeom prst="rect">
             <a:avLst/>
@@ -8816,7 +8906,7 @@
         <p:spPr>
           <a:xfrm>
             <a:off x="7511400" y="8595720"/>
-            <a:ext cx="3235680" cy="650880"/>
+            <a:ext cx="3234600" cy="649800"/>
           </a:xfrm>
           <a:prstGeom prst="rect">
             <a:avLst/>
@@ -8861,39 +8951,16 @@
           </a:p>
         </p:txBody>
       </p:sp>
-      <p:pic>
-        <p:nvPicPr>
-          <p:cNvPr id="125" name="" descr=""/>
-          <p:cNvPicPr/>
-          <p:nvPr/>
-        </p:nvPicPr>
-        <p:blipFill>
-          <a:blip r:embed="rId1"/>
-          <a:stretch/>
-        </p:blipFill>
-        <p:spPr>
-          <a:xfrm>
-            <a:off x="3711600" y="3186000"/>
-            <a:ext cx="11911320" cy="4639680"/>
-          </a:xfrm>
-          <a:prstGeom prst="rect">
-            <a:avLst/>
-          </a:prstGeom>
-          <a:ln w="0">
-            <a:noFill/>
-          </a:ln>
-        </p:spPr>
-      </p:pic>
       <p:sp>
         <p:nvSpPr>
-          <p:cNvPr id="126" name=""/>
+          <p:cNvPr id="125" name=""/>
           <p:cNvSpPr/>
           <p:nvPr/>
         </p:nvSpPr>
         <p:spPr>
           <a:xfrm>
-            <a:off x="15278760" y="8458200"/>
-            <a:ext cx="4379040" cy="1369800"/>
+            <a:off x="13716000" y="8686800"/>
+            <a:ext cx="5714280" cy="1368720"/>
           </a:xfrm>
           <a:prstGeom prst="rect">
             <a:avLst/>
@@ -8927,7 +8994,7 @@
                 <a:latin typeface="Times New Roman"/>
                 <a:ea typeface="Times New Roman"/>
               </a:rPr>
-              <a:t>DS1- store data</a:t>
+              <a:t>DS1- User data,Location history,Alert record</a:t>
             </a:r>
             <a:endParaRPr b="0" lang="en-US" sz="2400" spc="-1" strike="noStrike">
               <a:solidFill>
@@ -8950,7 +9017,7 @@
                 <a:latin typeface="Times New Roman"/>
                 <a:ea typeface="Times New Roman"/>
               </a:rPr>
-              <a:t>DS2-retrive data</a:t>
+              <a:t>DS2-User data,Location history,Alert record</a:t>
             </a:r>
             <a:endParaRPr b="0" lang="en-US" sz="2400" spc="-1" strike="noStrike">
               <a:solidFill>
@@ -8961,6 +9028,29 @@
           </a:p>
         </p:txBody>
       </p:sp>
+      <p:pic>
+        <p:nvPicPr>
+          <p:cNvPr id="126" name="" descr=""/>
+          <p:cNvPicPr/>
+          <p:nvPr/>
+        </p:nvPicPr>
+        <p:blipFill>
+          <a:blip r:embed="rId1"/>
+          <a:stretch/>
+        </p:blipFill>
+        <p:spPr>
+          <a:xfrm>
+            <a:off x="3726360" y="2743200"/>
+            <a:ext cx="12610440" cy="4912920"/>
+          </a:xfrm>
+          <a:prstGeom prst="rect">
+            <a:avLst/>
+          </a:prstGeom>
+          <a:ln w="0">
+            <a:noFill/>
+          </a:ln>
+        </p:spPr>
+      </p:pic>
     </p:spTree>
   </p:cSld>
   <mc:AlternateContent>
@@ -9003,8 +9093,8 @@
         </p:blipFill>
         <p:spPr>
           <a:xfrm>
-            <a:off x="4401360" y="2286000"/>
-            <a:ext cx="10698120" cy="7530840"/>
+            <a:off x="4389840" y="2070720"/>
+            <a:ext cx="10697040" cy="7529760"/>
           </a:xfrm>
           <a:prstGeom prst="rect">
             <a:avLst/>
@@ -9023,7 +9113,7 @@
         <p:spPr>
           <a:xfrm>
             <a:off x="8121240" y="10092240"/>
-            <a:ext cx="3765960" cy="650880"/>
+            <a:ext cx="3764880" cy="649800"/>
           </a:xfrm>
           <a:prstGeom prst="rect">
             <a:avLst/>
@@ -9076,8 +9166,8 @@
         </p:nvSpPr>
         <p:spPr>
           <a:xfrm>
-            <a:off x="16002000" y="9601200"/>
-            <a:ext cx="3573000" cy="762840"/>
+            <a:off x="13258800" y="9750960"/>
+            <a:ext cx="6135840" cy="1100520"/>
           </a:xfrm>
           <a:prstGeom prst="rect">
             <a:avLst/>
@@ -9111,7 +9201,7 @@
                 <a:latin typeface="Times New Roman"/>
                 <a:ea typeface="Times New Roman"/>
               </a:rPr>
-              <a:t>DS1- retrive</a:t>
+              <a:t>DS1- User data,Location history,Alert record,Environmental data</a:t>
             </a:r>
             <a:endParaRPr b="0" lang="en-US" sz="2400" spc="-1" strike="noStrike">
               <a:solidFill>
@@ -9134,7 +9224,7 @@
                 <a:latin typeface="Times New Roman"/>
                 <a:ea typeface="Times New Roman"/>
               </a:rPr>
-              <a:t>DS2-store</a:t>
+              <a:t>DS2-User data,Location history,Alert record</a:t>
             </a:r>
             <a:endParaRPr b="0" lang="en-US" sz="2400" spc="-1" strike="noStrike">
               <a:solidFill>
@@ -9188,7 +9278,7 @@
         <p:spPr>
           <a:xfrm>
             <a:off x="3082680" y="1932480"/>
-            <a:ext cx="13374720" cy="7997400"/>
+            <a:ext cx="13373640" cy="7996320"/>
           </a:xfrm>
           <a:prstGeom prst="rect">
             <a:avLst/>
@@ -9207,7 +9297,7 @@
         <p:spPr>
           <a:xfrm>
             <a:off x="9340200" y="10396800"/>
-            <a:ext cx="3235680" cy="650880"/>
+            <a:ext cx="3234600" cy="649800"/>
           </a:xfrm>
           <a:prstGeom prst="rect">
             <a:avLst/>
@@ -9261,7 +9351,7 @@
         <p:spPr>
           <a:xfrm>
             <a:off x="15856200" y="9931680"/>
-            <a:ext cx="3573000" cy="762840"/>
+            <a:ext cx="3571920" cy="761760"/>
           </a:xfrm>
           <a:prstGeom prst="rect">
             <a:avLst/>
@@ -9368,15 +9458,15 @@
         <p:spPr>
           <a:xfrm>
             <a:off x="2982960" y="712800"/>
-            <a:ext cx="53280" cy="53280"/>
+            <a:ext cx="52200" cy="52200"/>
           </a:xfrm>
           <a:custGeom>
             <a:avLst/>
             <a:gdLst>
-              <a:gd name="textAreaLeft" fmla="*/ 0 w 53280"/>
-              <a:gd name="textAreaRight" fmla="*/ 57240 w 53280"/>
-              <a:gd name="textAreaTop" fmla="*/ 0 h 53280"/>
-              <a:gd name="textAreaBottom" fmla="*/ 57240 h 53280"/>
+              <a:gd name="textAreaLeft" fmla="*/ 0 w 52200"/>
+              <a:gd name="textAreaRight" fmla="*/ 57240 w 52200"/>
+              <a:gd name="textAreaTop" fmla="*/ 0 h 52200"/>
+              <a:gd name="textAreaBottom" fmla="*/ 57240 h 52200"/>
             </a:gdLst>
             <a:ahLst/>
             <a:rect l="textAreaLeft" t="textAreaTop" r="textAreaRight" b="textAreaBottom"/>
@@ -9551,15 +9641,15 @@
         <p:spPr>
           <a:xfrm>
             <a:off x="2998800" y="725400"/>
-            <a:ext cx="21600" cy="27720"/>
+            <a:ext cx="20520" cy="26640"/>
           </a:xfrm>
           <a:custGeom>
             <a:avLst/>
             <a:gdLst>
-              <a:gd name="textAreaLeft" fmla="*/ 0 w 21600"/>
-              <a:gd name="textAreaRight" fmla="*/ 25560 w 21600"/>
-              <a:gd name="textAreaTop" fmla="*/ 0 h 27720"/>
-              <a:gd name="textAreaBottom" fmla="*/ 31680 h 27720"/>
+              <a:gd name="textAreaLeft" fmla="*/ 0 w 20520"/>
+              <a:gd name="textAreaRight" fmla="*/ 25560 w 20520"/>
+              <a:gd name="textAreaTop" fmla="*/ 0 h 26640"/>
+              <a:gd name="textAreaBottom" fmla="*/ 31680 h 26640"/>
             </a:gdLst>
             <a:ahLst/>
             <a:rect l="textAreaLeft" t="textAreaTop" r="textAreaRight" b="textAreaBottom"/>
@@ -9729,7 +9819,7 @@
         <p:spPr>
           <a:xfrm>
             <a:off x="18627840" y="10253160"/>
-            <a:ext cx="1201320" cy="860400"/>
+            <a:ext cx="1200240" cy="859320"/>
           </a:xfrm>
           <a:prstGeom prst="rect">
             <a:avLst/>
@@ -9771,7 +9861,7 @@
                 <a:tab algn="l" pos="0"/>
               </a:tabLst>
             </a:pPr>
-            <a:fld id="{C42218A1-855C-41D6-9F93-679358512084}" type="slidenum">
+            <a:fld id="{9DF3E73C-6929-4005-A0BB-2402730E3E10}" type="slidenum">
               <a:rPr b="0" lang="en-IN" sz="2200" spc="-1" strike="noStrike">
                 <a:solidFill>
                   <a:schemeClr val="dk2"/>
@@ -9799,7 +9889,7 @@
         <p:spPr>
           <a:xfrm>
             <a:off x="5057640" y="290520"/>
-            <a:ext cx="9066960" cy="635760"/>
+            <a:ext cx="9065880" cy="634680"/>
           </a:xfrm>
           <a:prstGeom prst="rect">
             <a:avLst/>
@@ -9856,7 +9946,7 @@
         <p:spPr>
           <a:xfrm>
             <a:off x="554400" y="2341440"/>
-            <a:ext cx="18659880" cy="7889040"/>
+            <a:ext cx="18658800" cy="7887960"/>
           </a:xfrm>
           <a:prstGeom prst="rect">
             <a:avLst/>
@@ -10254,15 +10344,15 @@
         <p:spPr>
           <a:xfrm>
             <a:off x="2982960" y="712800"/>
-            <a:ext cx="53280" cy="53280"/>
+            <a:ext cx="52200" cy="52200"/>
           </a:xfrm>
           <a:custGeom>
             <a:avLst/>
             <a:gdLst>
-              <a:gd name="textAreaLeft" fmla="*/ 0 w 53280"/>
-              <a:gd name="textAreaRight" fmla="*/ 57240 w 53280"/>
-              <a:gd name="textAreaTop" fmla="*/ 0 h 53280"/>
-              <a:gd name="textAreaBottom" fmla="*/ 57240 h 53280"/>
+              <a:gd name="textAreaLeft" fmla="*/ 0 w 52200"/>
+              <a:gd name="textAreaRight" fmla="*/ 57240 w 52200"/>
+              <a:gd name="textAreaTop" fmla="*/ 0 h 52200"/>
+              <a:gd name="textAreaBottom" fmla="*/ 57240 h 52200"/>
             </a:gdLst>
             <a:ahLst/>
             <a:rect l="textAreaLeft" t="textAreaTop" r="textAreaRight" b="textAreaBottom"/>
@@ -10437,15 +10527,15 @@
         <p:spPr>
           <a:xfrm>
             <a:off x="2998800" y="725400"/>
-            <a:ext cx="21600" cy="27720"/>
+            <a:ext cx="20520" cy="26640"/>
           </a:xfrm>
           <a:custGeom>
             <a:avLst/>
             <a:gdLst>
-              <a:gd name="textAreaLeft" fmla="*/ 0 w 21600"/>
-              <a:gd name="textAreaRight" fmla="*/ 25560 w 21600"/>
-              <a:gd name="textAreaTop" fmla="*/ 0 h 27720"/>
-              <a:gd name="textAreaBottom" fmla="*/ 31680 h 27720"/>
+              <a:gd name="textAreaLeft" fmla="*/ 0 w 20520"/>
+              <a:gd name="textAreaRight" fmla="*/ 25560 w 20520"/>
+              <a:gd name="textAreaTop" fmla="*/ 0 h 26640"/>
+              <a:gd name="textAreaBottom" fmla="*/ 31680 h 26640"/>
             </a:gdLst>
             <a:ahLst/>
             <a:rect l="textAreaLeft" t="textAreaTop" r="textAreaRight" b="textAreaBottom"/>
@@ -10615,7 +10705,7 @@
         <p:spPr>
           <a:xfrm>
             <a:off x="18627840" y="10253160"/>
-            <a:ext cx="1201320" cy="860400"/>
+            <a:ext cx="1200240" cy="859320"/>
           </a:xfrm>
           <a:prstGeom prst="rect">
             <a:avLst/>
@@ -10657,7 +10747,7 @@
                 <a:tab algn="l" pos="0"/>
               </a:tabLst>
             </a:pPr>
-            <a:fld id="{70B8BD2E-E5E8-48A6-839F-497A8B69B25C}" type="slidenum">
+            <a:fld id="{7A2CD0C0-1147-4CC9-B8B9-7A28ACE0B69A}" type="slidenum">
               <a:rPr b="0" lang="en-IN" sz="2200" spc="-1" strike="noStrike">
                 <a:solidFill>
                   <a:schemeClr val="dk2"/>
@@ -10685,7 +10775,7 @@
         <p:spPr>
           <a:xfrm>
             <a:off x="905040" y="2229840"/>
-            <a:ext cx="18523800" cy="9079560"/>
+            <a:ext cx="18522720" cy="9079560"/>
           </a:xfrm>
           <a:prstGeom prst="rect">
             <a:avLst/>
@@ -11058,7 +11148,7 @@
         <p:spPr>
           <a:xfrm>
             <a:off x="5057640" y="290520"/>
-            <a:ext cx="9066960" cy="635760"/>
+            <a:ext cx="9065880" cy="634680"/>
           </a:xfrm>
           <a:prstGeom prst="rect">
             <a:avLst/>
@@ -11177,15 +11267,15 @@
         <p:spPr>
           <a:xfrm>
             <a:off x="2982960" y="712800"/>
-            <a:ext cx="53280" cy="53280"/>
+            <a:ext cx="52200" cy="52200"/>
           </a:xfrm>
           <a:custGeom>
             <a:avLst/>
             <a:gdLst>
-              <a:gd name="textAreaLeft" fmla="*/ 0 w 53280"/>
-              <a:gd name="textAreaRight" fmla="*/ 57240 w 53280"/>
-              <a:gd name="textAreaTop" fmla="*/ 0 h 53280"/>
-              <a:gd name="textAreaBottom" fmla="*/ 57240 h 53280"/>
+              <a:gd name="textAreaLeft" fmla="*/ 0 w 52200"/>
+              <a:gd name="textAreaRight" fmla="*/ 57240 w 52200"/>
+              <a:gd name="textAreaTop" fmla="*/ 0 h 52200"/>
+              <a:gd name="textAreaBottom" fmla="*/ 57240 h 52200"/>
             </a:gdLst>
             <a:ahLst/>
             <a:rect l="textAreaLeft" t="textAreaTop" r="textAreaRight" b="textAreaBottom"/>
@@ -11360,15 +11450,15 @@
         <p:spPr>
           <a:xfrm>
             <a:off x="2998800" y="725400"/>
-            <a:ext cx="21600" cy="27720"/>
+            <a:ext cx="20520" cy="26640"/>
           </a:xfrm>
           <a:custGeom>
             <a:avLst/>
             <a:gdLst>
-              <a:gd name="textAreaLeft" fmla="*/ 0 w 21600"/>
-              <a:gd name="textAreaRight" fmla="*/ 25560 w 21600"/>
-              <a:gd name="textAreaTop" fmla="*/ 0 h 27720"/>
-              <a:gd name="textAreaBottom" fmla="*/ 31680 h 27720"/>
+              <a:gd name="textAreaLeft" fmla="*/ 0 w 20520"/>
+              <a:gd name="textAreaRight" fmla="*/ 25560 w 20520"/>
+              <a:gd name="textAreaTop" fmla="*/ 0 h 26640"/>
+              <a:gd name="textAreaBottom" fmla="*/ 31680 h 26640"/>
             </a:gdLst>
             <a:ahLst/>
             <a:rect l="textAreaLeft" t="textAreaTop" r="textAreaRight" b="textAreaBottom"/>
@@ -11538,7 +11628,7 @@
         <p:spPr>
           <a:xfrm>
             <a:off x="18627840" y="10253160"/>
-            <a:ext cx="1201320" cy="860400"/>
+            <a:ext cx="1200240" cy="859320"/>
           </a:xfrm>
           <a:prstGeom prst="rect">
             <a:avLst/>
@@ -11580,7 +11670,7 @@
                 <a:tab algn="l" pos="0"/>
               </a:tabLst>
             </a:pPr>
-            <a:fld id="{54AC211B-B42E-4CF1-8335-48D4E3FA3102}" type="slidenum">
+            <a:fld id="{EC02B047-1CA5-4B17-B90B-475987C5BC7B}" type="slidenum">
               <a:rPr b="0" lang="en-IN" sz="2200" spc="-1" strike="noStrike">
                 <a:solidFill>
                   <a:schemeClr val="dk2"/>
@@ -11608,7 +11698,7 @@
         <p:spPr>
           <a:xfrm>
             <a:off x="1008000" y="2411280"/>
-            <a:ext cx="18523800" cy="7795800"/>
+            <a:ext cx="18522720" cy="7795800"/>
           </a:xfrm>
           <a:prstGeom prst="rect">
             <a:avLst/>
@@ -11919,7 +12009,7 @@
         <p:spPr>
           <a:xfrm>
             <a:off x="5040000" y="971640"/>
-            <a:ext cx="9067320" cy="636120"/>
+            <a:ext cx="9066240" cy="635040"/>
           </a:xfrm>
           <a:prstGeom prst="rect">
             <a:avLst/>
@@ -12006,15 +12096,15 @@
         <p:spPr>
           <a:xfrm>
             <a:off x="2982960" y="712800"/>
-            <a:ext cx="53280" cy="53280"/>
+            <a:ext cx="52200" cy="52200"/>
           </a:xfrm>
           <a:custGeom>
             <a:avLst/>
             <a:gdLst>
-              <a:gd name="textAreaLeft" fmla="*/ 0 w 53280"/>
-              <a:gd name="textAreaRight" fmla="*/ 57240 w 53280"/>
-              <a:gd name="textAreaTop" fmla="*/ 0 h 53280"/>
-              <a:gd name="textAreaBottom" fmla="*/ 57240 h 53280"/>
+              <a:gd name="textAreaLeft" fmla="*/ 0 w 52200"/>
+              <a:gd name="textAreaRight" fmla="*/ 57240 w 52200"/>
+              <a:gd name="textAreaTop" fmla="*/ 0 h 52200"/>
+              <a:gd name="textAreaBottom" fmla="*/ 57240 h 52200"/>
             </a:gdLst>
             <a:ahLst/>
             <a:rect l="textAreaLeft" t="textAreaTop" r="textAreaRight" b="textAreaBottom"/>
@@ -12189,15 +12279,15 @@
         <p:spPr>
           <a:xfrm>
             <a:off x="2998800" y="725400"/>
-            <a:ext cx="21600" cy="27720"/>
+            <a:ext cx="20520" cy="26640"/>
           </a:xfrm>
           <a:custGeom>
             <a:avLst/>
             <a:gdLst>
-              <a:gd name="textAreaLeft" fmla="*/ 0 w 21600"/>
-              <a:gd name="textAreaRight" fmla="*/ 25560 w 21600"/>
-              <a:gd name="textAreaTop" fmla="*/ 0 h 27720"/>
-              <a:gd name="textAreaBottom" fmla="*/ 31680 h 27720"/>
+              <a:gd name="textAreaLeft" fmla="*/ 0 w 20520"/>
+              <a:gd name="textAreaRight" fmla="*/ 25560 w 20520"/>
+              <a:gd name="textAreaTop" fmla="*/ 0 h 26640"/>
+              <a:gd name="textAreaBottom" fmla="*/ 31680 h 26640"/>
             </a:gdLst>
             <a:ahLst/>
             <a:rect l="textAreaLeft" t="textAreaTop" r="textAreaRight" b="textAreaBottom"/>
@@ -12367,7 +12457,7 @@
         <p:spPr>
           <a:xfrm>
             <a:off x="18627840" y="10253160"/>
-            <a:ext cx="1201320" cy="860400"/>
+            <a:ext cx="1200240" cy="859320"/>
           </a:xfrm>
           <a:prstGeom prst="rect">
             <a:avLst/>
@@ -12409,7 +12499,7 @@
                 <a:tab algn="l" pos="0"/>
               </a:tabLst>
             </a:pPr>
-            <a:fld id="{C8D223E7-E188-42AC-A592-BE6DF96B2283}" type="slidenum">
+            <a:fld id="{8A9203FC-8159-41F7-AA13-5E822C0B485E}" type="slidenum">
               <a:rPr b="0" lang="en-IN" sz="2200" spc="-1" strike="noStrike">
                 <a:solidFill>
                   <a:schemeClr val="dk2"/>
@@ -12437,7 +12527,7 @@
         <p:spPr>
           <a:xfrm>
             <a:off x="5029200" y="735840"/>
-            <a:ext cx="9066960" cy="635760"/>
+            <a:ext cx="9065880" cy="634680"/>
           </a:xfrm>
           <a:prstGeom prst="rect">
             <a:avLst/>
@@ -13145,15 +13235,15 @@
         <p:spPr>
           <a:xfrm>
             <a:off x="2982960" y="712800"/>
-            <a:ext cx="53280" cy="53280"/>
+            <a:ext cx="52200" cy="52200"/>
           </a:xfrm>
           <a:custGeom>
             <a:avLst/>
             <a:gdLst>
-              <a:gd name="textAreaLeft" fmla="*/ 0 w 53280"/>
-              <a:gd name="textAreaRight" fmla="*/ 57240 w 53280"/>
-              <a:gd name="textAreaTop" fmla="*/ 0 h 53280"/>
-              <a:gd name="textAreaBottom" fmla="*/ 57240 h 53280"/>
+              <a:gd name="textAreaLeft" fmla="*/ 0 w 52200"/>
+              <a:gd name="textAreaRight" fmla="*/ 57240 w 52200"/>
+              <a:gd name="textAreaTop" fmla="*/ 0 h 52200"/>
+              <a:gd name="textAreaBottom" fmla="*/ 57240 h 52200"/>
             </a:gdLst>
             <a:ahLst/>
             <a:rect l="textAreaLeft" t="textAreaTop" r="textAreaRight" b="textAreaBottom"/>
@@ -13328,15 +13418,15 @@
         <p:spPr>
           <a:xfrm>
             <a:off x="2998800" y="725400"/>
-            <a:ext cx="21600" cy="27720"/>
+            <a:ext cx="20520" cy="26640"/>
           </a:xfrm>
           <a:custGeom>
             <a:avLst/>
             <a:gdLst>
-              <a:gd name="textAreaLeft" fmla="*/ 0 w 21600"/>
-              <a:gd name="textAreaRight" fmla="*/ 25560 w 21600"/>
-              <a:gd name="textAreaTop" fmla="*/ 0 h 27720"/>
-              <a:gd name="textAreaBottom" fmla="*/ 31680 h 27720"/>
+              <a:gd name="textAreaLeft" fmla="*/ 0 w 20520"/>
+              <a:gd name="textAreaRight" fmla="*/ 25560 w 20520"/>
+              <a:gd name="textAreaTop" fmla="*/ 0 h 26640"/>
+              <a:gd name="textAreaBottom" fmla="*/ 31680 h 26640"/>
             </a:gdLst>
             <a:ahLst/>
             <a:rect l="textAreaLeft" t="textAreaTop" r="textAreaRight" b="textAreaBottom"/>
@@ -13506,7 +13596,7 @@
         <p:spPr>
           <a:xfrm>
             <a:off x="18627840" y="10253160"/>
-            <a:ext cx="1201320" cy="860400"/>
+            <a:ext cx="1200240" cy="859320"/>
           </a:xfrm>
           <a:prstGeom prst="rect">
             <a:avLst/>
@@ -13548,7 +13638,7 @@
                 <a:tab algn="l" pos="0"/>
               </a:tabLst>
             </a:pPr>
-            <a:fld id="{731BB5C3-58D4-4C94-85B7-0A2F6CD35950}" type="slidenum">
+            <a:fld id="{E14C8A38-FE96-47A2-AD15-1D7079987D24}" type="slidenum">
               <a:rPr b="0" lang="en-IN" sz="2200" spc="-1" strike="noStrike">
                 <a:solidFill>
                   <a:schemeClr val="dk2"/>
@@ -13576,7 +13666,7 @@
         <p:spPr>
           <a:xfrm>
             <a:off x="5057640" y="290520"/>
-            <a:ext cx="9066960" cy="635760"/>
+            <a:ext cx="9065880" cy="634680"/>
           </a:xfrm>
           <a:prstGeom prst="rect">
             <a:avLst/>
@@ -15678,7 +15768,7 @@
         <p:spPr>
           <a:xfrm>
             <a:off x="1320480" y="2081160"/>
-            <a:ext cx="9422640" cy="708480"/>
+            <a:ext cx="9421560" cy="707400"/>
           </a:xfrm>
           <a:prstGeom prst="rect">
             <a:avLst/>
@@ -15762,15 +15852,15 @@
         <p:spPr>
           <a:xfrm>
             <a:off x="2982960" y="712800"/>
-            <a:ext cx="53280" cy="53280"/>
+            <a:ext cx="52200" cy="52200"/>
           </a:xfrm>
           <a:custGeom>
             <a:avLst/>
             <a:gdLst>
-              <a:gd name="textAreaLeft" fmla="*/ 0 w 53280"/>
-              <a:gd name="textAreaRight" fmla="*/ 57240 w 53280"/>
-              <a:gd name="textAreaTop" fmla="*/ 0 h 53280"/>
-              <a:gd name="textAreaBottom" fmla="*/ 57240 h 53280"/>
+              <a:gd name="textAreaLeft" fmla="*/ 0 w 52200"/>
+              <a:gd name="textAreaRight" fmla="*/ 57240 w 52200"/>
+              <a:gd name="textAreaTop" fmla="*/ 0 h 52200"/>
+              <a:gd name="textAreaBottom" fmla="*/ 57240 h 52200"/>
             </a:gdLst>
             <a:ahLst/>
             <a:rect l="textAreaLeft" t="textAreaTop" r="textAreaRight" b="textAreaBottom"/>
@@ -15945,15 +16035,15 @@
         <p:spPr>
           <a:xfrm>
             <a:off x="2998800" y="725400"/>
-            <a:ext cx="21600" cy="27720"/>
+            <a:ext cx="20520" cy="26640"/>
           </a:xfrm>
           <a:custGeom>
             <a:avLst/>
             <a:gdLst>
-              <a:gd name="textAreaLeft" fmla="*/ 0 w 21600"/>
-              <a:gd name="textAreaRight" fmla="*/ 25560 w 21600"/>
-              <a:gd name="textAreaTop" fmla="*/ 0 h 27720"/>
-              <a:gd name="textAreaBottom" fmla="*/ 31680 h 27720"/>
+              <a:gd name="textAreaLeft" fmla="*/ 0 w 20520"/>
+              <a:gd name="textAreaRight" fmla="*/ 25560 w 20520"/>
+              <a:gd name="textAreaTop" fmla="*/ 0 h 26640"/>
+              <a:gd name="textAreaBottom" fmla="*/ 31680 h 26640"/>
             </a:gdLst>
             <a:ahLst/>
             <a:rect l="textAreaLeft" t="textAreaTop" r="textAreaRight" b="textAreaBottom"/>
@@ -16123,7 +16213,7 @@
         <p:spPr>
           <a:xfrm>
             <a:off x="18627840" y="10253160"/>
-            <a:ext cx="1201320" cy="860400"/>
+            <a:ext cx="1200240" cy="859320"/>
           </a:xfrm>
           <a:prstGeom prst="rect">
             <a:avLst/>
@@ -16165,7 +16255,7 @@
                 <a:tab algn="l" pos="0"/>
               </a:tabLst>
             </a:pPr>
-            <a:fld id="{896479BC-91CE-4957-B316-67E0CA5890B2}" type="slidenum">
+            <a:fld id="{06DEB554-C153-4C15-8984-B2A92CC58D44}" type="slidenum">
               <a:rPr b="0" lang="en-IN" sz="2200" spc="-1" strike="noStrike">
                 <a:solidFill>
                   <a:schemeClr val="dk2"/>
@@ -16193,7 +16283,7 @@
         <p:spPr>
           <a:xfrm>
             <a:off x="995400" y="2378160"/>
-            <a:ext cx="18523800" cy="6031440"/>
+            <a:ext cx="18522720" cy="5122440"/>
           </a:xfrm>
           <a:prstGeom prst="rect">
             <a:avLst/>
@@ -16389,7 +16479,7 @@
                 <a:latin typeface="times new roman"/>
                 <a:ea typeface="Arial"/>
               </a:rPr>
-              <a:t>Python allows flexible backend scripting for data processing, alert logic, and easy future enhancements.</a:t>
+              <a:t>Leaflet.js integrates interactive maps for live location tracking and visualization of all field nodes.</a:t>
             </a:r>
             <a:endParaRPr b="0" lang="en-US" sz="3200" spc="-1" strike="noStrike">
               <a:solidFill>
@@ -16426,43 +16516,6 @@
                 <a:latin typeface="times new roman"/>
                 <a:ea typeface="Arial"/>
               </a:rPr>
-              <a:t>Leaflet.js integrates interactive maps for live location tracking and visualization of all field nodes.</a:t>
-            </a:r>
-            <a:endParaRPr b="0" lang="en-US" sz="3200" spc="-1" strike="noStrike">
-              <a:solidFill>
-                <a:srgbClr val="000000"/>
-              </a:solidFill>
-              <a:latin typeface="Arial"/>
-            </a:endParaRPr>
-          </a:p>
-          <a:p>
-            <a:pPr marL="216000" indent="-216000">
-              <a:lnSpc>
-                <a:spcPct val="100000"/>
-              </a:lnSpc>
-              <a:spcBef>
-                <a:spcPts val="1757"/>
-              </a:spcBef>
-              <a:spcAft>
-                <a:spcPts val="1559"/>
-              </a:spcAft>
-              <a:buClr>
-                <a:srgbClr val="000000"/>
-              </a:buClr>
-              <a:buFont typeface="Symbol" charset="2"/>
-              <a:buChar char=""/>
-              <a:tabLst>
-                <a:tab algn="l" pos="0"/>
-              </a:tabLst>
-            </a:pPr>
-            <a:r>
-              <a:rPr b="0" lang="en-US" sz="3200" spc="-1" strike="noStrike">
-                <a:solidFill>
-                  <a:srgbClr val="000000"/>
-                </a:solidFill>
-                <a:latin typeface="times new roman"/>
-                <a:ea typeface="Arial"/>
-              </a:rPr>
               <a:t>Arduino IDE simplifies firmware development and rapid prototyping for ESP32-based sensor nodes.</a:t>
             </a:r>
             <a:endParaRPr b="0" lang="en-US" sz="3200" spc="-1" strike="noStrike">
@@ -16483,7 +16536,7 @@
         <p:spPr>
           <a:xfrm>
             <a:off x="5057640" y="290520"/>
-            <a:ext cx="9066960" cy="635760"/>
+            <a:ext cx="9065880" cy="634680"/>
           </a:xfrm>
           <a:prstGeom prst="rect">
             <a:avLst/>
@@ -16540,7 +16593,7 @@
         <p:spPr>
           <a:xfrm>
             <a:off x="1025280" y="6143400"/>
-            <a:ext cx="18523800" cy="455400"/>
+            <a:ext cx="18522720" cy="455400"/>
           </a:xfrm>
           <a:prstGeom prst="rect">
             <a:avLst/>
@@ -16633,15 +16686,15 @@
         <p:spPr>
           <a:xfrm>
             <a:off x="2982960" y="712800"/>
-            <a:ext cx="53280" cy="53280"/>
+            <a:ext cx="52200" cy="52200"/>
           </a:xfrm>
           <a:custGeom>
             <a:avLst/>
             <a:gdLst>
-              <a:gd name="textAreaLeft" fmla="*/ 0 w 53280"/>
-              <a:gd name="textAreaRight" fmla="*/ 57240 w 53280"/>
-              <a:gd name="textAreaTop" fmla="*/ 0 h 53280"/>
-              <a:gd name="textAreaBottom" fmla="*/ 57240 h 53280"/>
+              <a:gd name="textAreaLeft" fmla="*/ 0 w 52200"/>
+              <a:gd name="textAreaRight" fmla="*/ 57240 w 52200"/>
+              <a:gd name="textAreaTop" fmla="*/ 0 h 52200"/>
+              <a:gd name="textAreaBottom" fmla="*/ 57240 h 52200"/>
             </a:gdLst>
             <a:ahLst/>
             <a:rect l="textAreaLeft" t="textAreaTop" r="textAreaRight" b="textAreaBottom"/>
@@ -16816,15 +16869,15 @@
         <p:spPr>
           <a:xfrm>
             <a:off x="2998800" y="725400"/>
-            <a:ext cx="21600" cy="27720"/>
+            <a:ext cx="20520" cy="26640"/>
           </a:xfrm>
           <a:custGeom>
             <a:avLst/>
             <a:gdLst>
-              <a:gd name="textAreaLeft" fmla="*/ 0 w 21600"/>
-              <a:gd name="textAreaRight" fmla="*/ 25560 w 21600"/>
-              <a:gd name="textAreaTop" fmla="*/ 0 h 27720"/>
-              <a:gd name="textAreaBottom" fmla="*/ 31680 h 27720"/>
+              <a:gd name="textAreaLeft" fmla="*/ 0 w 20520"/>
+              <a:gd name="textAreaRight" fmla="*/ 25560 w 20520"/>
+              <a:gd name="textAreaTop" fmla="*/ 0 h 26640"/>
+              <a:gd name="textAreaBottom" fmla="*/ 31680 h 26640"/>
             </a:gdLst>
             <a:ahLst/>
             <a:rect l="textAreaLeft" t="textAreaTop" r="textAreaRight" b="textAreaBottom"/>
@@ -16994,7 +17047,7 @@
         <p:spPr>
           <a:xfrm>
             <a:off x="18627840" y="10253160"/>
-            <a:ext cx="1201320" cy="860400"/>
+            <a:ext cx="1200240" cy="859320"/>
           </a:xfrm>
           <a:prstGeom prst="rect">
             <a:avLst/>
@@ -17036,7 +17089,7 @@
                 <a:tab algn="l" pos="0"/>
               </a:tabLst>
             </a:pPr>
-            <a:fld id="{AF4DA732-550E-4D4C-9CB2-671B0161F4CD}" type="slidenum">
+            <a:fld id="{B77A6E44-E22B-4A55-9BA6-D00FBCE34741}" type="slidenum">
               <a:rPr b="0" lang="en-IN" sz="2200" spc="-1" strike="noStrike">
                 <a:solidFill>
                   <a:schemeClr val="dk2"/>
@@ -17064,7 +17117,7 @@
         <p:spPr>
           <a:xfrm>
             <a:off x="1008000" y="2073240"/>
-            <a:ext cx="18523800" cy="8867880"/>
+            <a:ext cx="18522720" cy="8867880"/>
           </a:xfrm>
           <a:prstGeom prst="rect">
             <a:avLst/>
@@ -17437,7 +17490,7 @@
         <p:spPr>
           <a:xfrm>
             <a:off x="5057640" y="290520"/>
-            <a:ext cx="9525600" cy="636120"/>
+            <a:ext cx="9524520" cy="635040"/>
           </a:xfrm>
           <a:prstGeom prst="rect">
             <a:avLst/>
@@ -17524,15 +17577,15 @@
         <p:spPr>
           <a:xfrm>
             <a:off x="2982960" y="712800"/>
-            <a:ext cx="53280" cy="53280"/>
+            <a:ext cx="52200" cy="52200"/>
           </a:xfrm>
           <a:custGeom>
             <a:avLst/>
             <a:gdLst>
-              <a:gd name="textAreaLeft" fmla="*/ 0 w 53280"/>
-              <a:gd name="textAreaRight" fmla="*/ 57240 w 53280"/>
-              <a:gd name="textAreaTop" fmla="*/ 0 h 53280"/>
-              <a:gd name="textAreaBottom" fmla="*/ 57240 h 53280"/>
+              <a:gd name="textAreaLeft" fmla="*/ 0 w 52200"/>
+              <a:gd name="textAreaRight" fmla="*/ 57240 w 52200"/>
+              <a:gd name="textAreaTop" fmla="*/ 0 h 52200"/>
+              <a:gd name="textAreaBottom" fmla="*/ 57240 h 52200"/>
             </a:gdLst>
             <a:ahLst/>
             <a:rect l="textAreaLeft" t="textAreaTop" r="textAreaRight" b="textAreaBottom"/>
@@ -17707,15 +17760,15 @@
         <p:spPr>
           <a:xfrm>
             <a:off x="2998800" y="725400"/>
-            <a:ext cx="21600" cy="27720"/>
+            <a:ext cx="20520" cy="26640"/>
           </a:xfrm>
           <a:custGeom>
             <a:avLst/>
             <a:gdLst>
-              <a:gd name="textAreaLeft" fmla="*/ 0 w 21600"/>
-              <a:gd name="textAreaRight" fmla="*/ 25560 w 21600"/>
-              <a:gd name="textAreaTop" fmla="*/ 0 h 27720"/>
-              <a:gd name="textAreaBottom" fmla="*/ 31680 h 27720"/>
+              <a:gd name="textAreaLeft" fmla="*/ 0 w 20520"/>
+              <a:gd name="textAreaRight" fmla="*/ 25560 w 20520"/>
+              <a:gd name="textAreaTop" fmla="*/ 0 h 26640"/>
+              <a:gd name="textAreaBottom" fmla="*/ 31680 h 26640"/>
             </a:gdLst>
             <a:ahLst/>
             <a:rect l="textAreaLeft" t="textAreaTop" r="textAreaRight" b="textAreaBottom"/>
@@ -17885,7 +17938,7 @@
         <p:spPr>
           <a:xfrm>
             <a:off x="18627840" y="10253160"/>
-            <a:ext cx="1201320" cy="860400"/>
+            <a:ext cx="1200240" cy="859320"/>
           </a:xfrm>
           <a:prstGeom prst="rect">
             <a:avLst/>
@@ -17927,7 +17980,7 @@
                 <a:tab algn="l" pos="0"/>
               </a:tabLst>
             </a:pPr>
-            <a:fld id="{ACF2172D-432A-4DDC-A9CE-B9E864ED5837}" type="slidenum">
+            <a:fld id="{94F702FA-8AD6-49C5-8F6C-0B756B2DCAE5}" type="slidenum">
               <a:rPr b="0" lang="en-IN" sz="2200" spc="-1" strike="noStrike">
                 <a:solidFill>
                   <a:schemeClr val="dk2"/>
@@ -17955,7 +18008,7 @@
         <p:spPr>
           <a:xfrm>
             <a:off x="5057640" y="290520"/>
-            <a:ext cx="10636920" cy="636120"/>
+            <a:ext cx="10635840" cy="635040"/>
           </a:xfrm>
           <a:prstGeom prst="rect">
             <a:avLst/>
@@ -18815,7 +18868,7 @@
         <p:spPr>
           <a:xfrm>
             <a:off x="7523640" y="656280"/>
-            <a:ext cx="5054040" cy="1254600"/>
+            <a:ext cx="5052960" cy="1253520"/>
           </a:xfrm>
           <a:prstGeom prst="rect">
             <a:avLst/>
@@ -18869,7 +18922,7 @@
         </p:nvGraphicFramePr>
         <p:xfrm>
           <a:off x="1577520" y="2368440"/>
-          <a:ext cx="17352720" cy="5742000"/>
+          <a:ext cx="17352720" cy="3827520"/>
         </p:xfrm>
         <a:graphic>
           <a:graphicData uri="http://schemas.openxmlformats.org/drawingml/2006/table">
@@ -19493,358 +19546,6 @@
                   </a:tcPr>
                 </a:tc>
               </a:tr>
-              <a:tr h="956520">
-                <a:tc>
-                  <a:txBody>
-                    <a:bodyPr anchor="t">
-                      <a:noAutofit/>
-                    </a:bodyPr>
-                    <a:p>
-                      <a:pPr>
-                        <a:lnSpc>
-                          <a:spcPct val="100000"/>
-                        </a:lnSpc>
-                      </a:pPr>
-                      <a:r>
-                        <a:rPr b="0" lang="en-US" sz="2400" spc="-1" strike="noStrike">
-                          <a:solidFill>
-                            <a:srgbClr val="000000"/>
-                          </a:solidFill>
-                          <a:latin typeface="Times New Roman"/>
-                        </a:rPr>
-                        <a:t>3</a:t>
-                      </a:r>
-                      <a:endParaRPr b="0" lang="en-US" sz="2400" spc="-1" strike="noStrike">
-                        <a:solidFill>
-                          <a:srgbClr val="000000"/>
-                        </a:solidFill>
-                        <a:latin typeface="Arial"/>
-                      </a:endParaRPr>
-                    </a:p>
-                  </a:txBody>
-                  <a:tcPr anchor="t" marL="91440" marR="91440">
-                    <a:lnL w="12240">
-                      <a:solidFill>
-                        <a:srgbClr val="ffffff"/>
-                      </a:solidFill>
-                      <a:prstDash val="solid"/>
-                    </a:lnL>
-                    <a:lnR w="12240">
-                      <a:solidFill>
-                        <a:srgbClr val="ffffff"/>
-                      </a:solidFill>
-                      <a:prstDash val="solid"/>
-                    </a:lnR>
-                    <a:lnT w="12240">
-                      <a:solidFill>
-                        <a:srgbClr val="ffffff"/>
-                      </a:solidFill>
-                      <a:prstDash val="solid"/>
-                    </a:lnT>
-                    <a:lnB w="12240">
-                      <a:solidFill>
-                        <a:srgbClr val="ffffff"/>
-                      </a:solidFill>
-                      <a:prstDash val="solid"/>
-                    </a:lnB>
-                    <a:solidFill>
-                      <a:srgbClr val="cdd8fb"/>
-                    </a:solidFill>
-                  </a:tcPr>
-                </a:tc>
-                <a:tc>
-                  <a:txBody>
-                    <a:bodyPr anchor="t">
-                      <a:noAutofit/>
-                    </a:bodyPr>
-                    <a:p>
-                      <a:pPr>
-                        <a:lnSpc>
-                          <a:spcPct val="100000"/>
-                        </a:lnSpc>
-                      </a:pPr>
-                      <a:r>
-                        <a:rPr b="0" lang="en-US" sz="2400" spc="-1" strike="noStrike">
-                          <a:solidFill>
-                            <a:srgbClr val="000000"/>
-                          </a:solidFill>
-                          <a:latin typeface="Times New Roman"/>
-                        </a:rPr>
-                        <a:t>Budget</a:t>
-                      </a:r>
-                      <a:endParaRPr b="0" lang="en-US" sz="2400" spc="-1" strike="noStrike">
-                        <a:solidFill>
-                          <a:srgbClr val="000000"/>
-                        </a:solidFill>
-                        <a:latin typeface="Arial"/>
-                      </a:endParaRPr>
-                    </a:p>
-                  </a:txBody>
-                  <a:tcPr anchor="t" marL="91440" marR="91440">
-                    <a:lnL w="12240">
-                      <a:solidFill>
-                        <a:srgbClr val="ffffff"/>
-                      </a:solidFill>
-                      <a:prstDash val="solid"/>
-                    </a:lnL>
-                    <a:lnR w="12240">
-                      <a:solidFill>
-                        <a:srgbClr val="ffffff"/>
-                      </a:solidFill>
-                      <a:prstDash val="solid"/>
-                    </a:lnR>
-                    <a:lnT w="12240">
-                      <a:solidFill>
-                        <a:srgbClr val="ffffff"/>
-                      </a:solidFill>
-                      <a:prstDash val="solid"/>
-                    </a:lnT>
-                    <a:lnB w="12240">
-                      <a:solidFill>
-                        <a:srgbClr val="ffffff"/>
-                      </a:solidFill>
-                      <a:prstDash val="solid"/>
-                    </a:lnB>
-                    <a:solidFill>
-                      <a:srgbClr val="cdd8fb"/>
-                    </a:solidFill>
-                  </a:tcPr>
-                </a:tc>
-                <a:tc>
-                  <a:txBody>
-                    <a:bodyPr anchor="t">
-                      <a:noAutofit/>
-                    </a:bodyPr>
-                    <a:p>
-                      <a:pPr>
-                        <a:lnSpc>
-                          <a:spcPct val="100000"/>
-                        </a:lnSpc>
-                      </a:pPr>
-                      <a:r>
-                        <a:rPr b="0" lang="en-US" sz="2400" spc="-1" strike="noStrike">
-                          <a:solidFill>
-                            <a:srgbClr val="000000"/>
-                          </a:solidFill>
-                          <a:latin typeface="Times New Roman"/>
-                        </a:rPr>
-                        <a:t>Only low-cost, readily available components (ESP32, LoRa, BME280, GPS) are used; advanced modules or commercial IoT platforms are excluded.</a:t>
-                      </a:r>
-                      <a:endParaRPr b="0" lang="en-US" sz="2400" spc="-1" strike="noStrike">
-                        <a:solidFill>
-                          <a:srgbClr val="000000"/>
-                        </a:solidFill>
-                        <a:latin typeface="Arial"/>
-                      </a:endParaRPr>
-                    </a:p>
-                  </a:txBody>
-                  <a:tcPr anchor="t" marL="91440" marR="91440">
-                    <a:lnL w="12240">
-                      <a:solidFill>
-                        <a:srgbClr val="ffffff"/>
-                      </a:solidFill>
-                      <a:prstDash val="solid"/>
-                    </a:lnL>
-                    <a:lnR w="12240">
-                      <a:solidFill>
-                        <a:srgbClr val="ffffff"/>
-                      </a:solidFill>
-                      <a:prstDash val="solid"/>
-                    </a:lnR>
-                    <a:lnT w="12240">
-                      <a:solidFill>
-                        <a:srgbClr val="ffffff"/>
-                      </a:solidFill>
-                      <a:prstDash val="solid"/>
-                    </a:lnT>
-                    <a:lnB w="12240">
-                      <a:solidFill>
-                        <a:srgbClr val="ffffff"/>
-                      </a:solidFill>
-                      <a:prstDash val="solid"/>
-                    </a:lnB>
-                    <a:solidFill>
-                      <a:srgbClr val="cdd8fb"/>
-                    </a:solidFill>
-                  </a:tcPr>
-                </a:tc>
-              </a:tr>
-              <a:tr h="957960">
-                <a:tc>
-                  <a:txBody>
-                    <a:bodyPr anchor="t">
-                      <a:noAutofit/>
-                    </a:bodyPr>
-                    <a:p>
-                      <a:pPr>
-                        <a:lnSpc>
-                          <a:spcPct val="100000"/>
-                        </a:lnSpc>
-                      </a:pPr>
-                      <a:r>
-                        <a:rPr b="0" lang="en-US" sz="2400" spc="-1" strike="noStrike">
-                          <a:solidFill>
-                            <a:srgbClr val="000000"/>
-                          </a:solidFill>
-                          <a:latin typeface="Times New Roman"/>
-                        </a:rPr>
-                        <a:t>4</a:t>
-                      </a:r>
-                      <a:endParaRPr b="0" lang="en-US" sz="2400" spc="-1" strike="noStrike">
-                        <a:solidFill>
-                          <a:srgbClr val="000000"/>
-                        </a:solidFill>
-                        <a:latin typeface="Arial"/>
-                      </a:endParaRPr>
-                    </a:p>
-                  </a:txBody>
-                  <a:tcPr anchor="t" marL="91440" marR="91440">
-                    <a:lnL w="12240">
-                      <a:solidFill>
-                        <a:srgbClr val="ffffff"/>
-                      </a:solidFill>
-                      <a:prstDash val="solid"/>
-                    </a:lnL>
-                    <a:lnR w="12240">
-                      <a:solidFill>
-                        <a:srgbClr val="ffffff"/>
-                      </a:solidFill>
-                      <a:prstDash val="solid"/>
-                    </a:lnR>
-                    <a:lnT w="12240">
-                      <a:solidFill>
-                        <a:srgbClr val="ffffff"/>
-                      </a:solidFill>
-                      <a:prstDash val="solid"/>
-                    </a:lnT>
-                    <a:lnB w="12240">
-                      <a:solidFill>
-                        <a:srgbClr val="ffffff"/>
-                      </a:solidFill>
-                      <a:prstDash val="solid"/>
-                    </a:lnB>
-                    <a:solidFill>
-                      <a:srgbClr val="cdd8fb"/>
-                    </a:solidFill>
-                  </a:tcPr>
-                </a:tc>
-                <a:tc>
-                  <a:txBody>
-                    <a:bodyPr anchor="t">
-                      <a:noAutofit/>
-                    </a:bodyPr>
-                    <a:p>
-                      <a:pPr>
-                        <a:lnSpc>
-                          <a:spcPct val="100000"/>
-                        </a:lnSpc>
-                      </a:pPr>
-                      <a:r>
-                        <a:rPr b="0" lang="en-US" sz="2400" spc="-1" strike="noStrike">
-                          <a:solidFill>
-                            <a:srgbClr val="000000"/>
-                          </a:solidFill>
-                          <a:latin typeface="Times New Roman"/>
-                        </a:rPr>
-                        <a:t>Deployment</a:t>
-                      </a:r>
-                      <a:endParaRPr b="0" lang="en-US" sz="2400" spc="-1" strike="noStrike">
-                        <a:solidFill>
-                          <a:srgbClr val="000000"/>
-                        </a:solidFill>
-                        <a:latin typeface="Arial"/>
-                      </a:endParaRPr>
-                    </a:p>
-                  </a:txBody>
-                  <a:tcPr anchor="t" marL="91440" marR="91440">
-                    <a:lnL w="12240">
-                      <a:solidFill>
-                        <a:srgbClr val="ffffff"/>
-                      </a:solidFill>
-                      <a:prstDash val="solid"/>
-                    </a:lnL>
-                    <a:lnR w="12240">
-                      <a:solidFill>
-                        <a:srgbClr val="ffffff"/>
-                      </a:solidFill>
-                      <a:prstDash val="solid"/>
-                    </a:lnR>
-                    <a:lnT w="12240">
-                      <a:solidFill>
-                        <a:srgbClr val="ffffff"/>
-                      </a:solidFill>
-                      <a:prstDash val="solid"/>
-                    </a:lnT>
-                    <a:lnB w="12240">
-                      <a:solidFill>
-                        <a:srgbClr val="ffffff"/>
-                      </a:solidFill>
-                      <a:prstDash val="solid"/>
-                    </a:lnB>
-                    <a:solidFill>
-                      <a:srgbClr val="cdd8fb"/>
-                    </a:solidFill>
-                  </a:tcPr>
-                </a:tc>
-                <a:tc>
-                  <a:txBody>
-                    <a:bodyPr anchor="t">
-                      <a:noAutofit/>
-                    </a:bodyPr>
-                    <a:p>
-                      <a:pPr>
-                        <a:lnSpc>
-                          <a:spcPct val="100000"/>
-                        </a:lnSpc>
-                      </a:pPr>
-                      <a:r>
-                        <a:rPr b="0" lang="en-US" sz="2400" spc="-1" strike="noStrike">
-                          <a:solidFill>
-                            <a:srgbClr val="000000"/>
-                          </a:solidFill>
-                          <a:latin typeface="Times New Roman"/>
-                        </a:rPr>
-                        <a:t>System is designed for local or LAN-based deployment; cloud hosting and remote access are not implemented in the initial version.</a:t>
-                      </a:r>
-                      <a:endParaRPr b="0" lang="en-US" sz="2400" spc="-1" strike="noStrike">
-                        <a:solidFill>
-                          <a:srgbClr val="000000"/>
-                        </a:solidFill>
-                        <a:latin typeface="Arial"/>
-                      </a:endParaRPr>
-                    </a:p>
-                  </a:txBody>
-                  <a:tcPr anchor="t" marL="91440" marR="91440">
-                    <a:lnL w="12240">
-                      <a:solidFill>
-                        <a:srgbClr val="ffffff"/>
-                      </a:solidFill>
-                      <a:prstDash val="solid"/>
-                    </a:lnL>
-                    <a:lnR w="12240">
-                      <a:solidFill>
-                        <a:srgbClr val="ffffff"/>
-                      </a:solidFill>
-                      <a:prstDash val="solid"/>
-                    </a:lnR>
-                    <a:lnT w="12240">
-                      <a:solidFill>
-                        <a:srgbClr val="ffffff"/>
-                      </a:solidFill>
-                      <a:prstDash val="solid"/>
-                    </a:lnT>
-                    <a:lnB w="12240">
-                      <a:solidFill>
-                        <a:srgbClr val="ffffff"/>
-                      </a:solidFill>
-                      <a:prstDash val="solid"/>
-                    </a:lnB>
-                    <a:solidFill>
-                      <a:srgbClr val="cdd8fb"/>
-                    </a:solidFill>
-                  </a:tcPr>
-                </a:tc>
-              </a:tr>
               <a:tr h="957960">
                 <a:tc>
                   <a:txBody>
@@ -19864,7 +19565,7 @@
                           </a:solidFill>
                           <a:latin typeface="Arial"/>
                         </a:rPr>
-                        <a:t>5</a:t>
+                        <a:t>3</a:t>
                       </a:r>
                       <a:endParaRPr b="0" lang="en-US" sz="1800" spc="-1" strike="noStrike">
                         <a:solidFill>
@@ -20064,15 +19765,15 @@
         <p:spPr>
           <a:xfrm>
             <a:off x="2982960" y="712800"/>
-            <a:ext cx="53280" cy="53280"/>
+            <a:ext cx="52200" cy="52200"/>
           </a:xfrm>
           <a:custGeom>
             <a:avLst/>
             <a:gdLst>
-              <a:gd name="textAreaLeft" fmla="*/ 0 w 53280"/>
-              <a:gd name="textAreaRight" fmla="*/ 57240 w 53280"/>
-              <a:gd name="textAreaTop" fmla="*/ 0 h 53280"/>
-              <a:gd name="textAreaBottom" fmla="*/ 57240 h 53280"/>
+              <a:gd name="textAreaLeft" fmla="*/ 0 w 52200"/>
+              <a:gd name="textAreaRight" fmla="*/ 57240 w 52200"/>
+              <a:gd name="textAreaTop" fmla="*/ 0 h 52200"/>
+              <a:gd name="textAreaBottom" fmla="*/ 57240 h 52200"/>
             </a:gdLst>
             <a:ahLst/>
             <a:rect l="textAreaLeft" t="textAreaTop" r="textAreaRight" b="textAreaBottom"/>
@@ -20247,15 +19948,15 @@
         <p:spPr>
           <a:xfrm>
             <a:off x="2998800" y="725400"/>
-            <a:ext cx="21600" cy="27720"/>
+            <a:ext cx="20520" cy="26640"/>
           </a:xfrm>
           <a:custGeom>
             <a:avLst/>
             <a:gdLst>
-              <a:gd name="textAreaLeft" fmla="*/ 0 w 21600"/>
-              <a:gd name="textAreaRight" fmla="*/ 25560 w 21600"/>
-              <a:gd name="textAreaTop" fmla="*/ 0 h 27720"/>
-              <a:gd name="textAreaBottom" fmla="*/ 31680 h 27720"/>
+              <a:gd name="textAreaLeft" fmla="*/ 0 w 20520"/>
+              <a:gd name="textAreaRight" fmla="*/ 25560 w 20520"/>
+              <a:gd name="textAreaTop" fmla="*/ 0 h 26640"/>
+              <a:gd name="textAreaBottom" fmla="*/ 31680 h 26640"/>
             </a:gdLst>
             <a:ahLst/>
             <a:rect l="textAreaLeft" t="textAreaTop" r="textAreaRight" b="textAreaBottom"/>
@@ -20425,7 +20126,7 @@
         <p:spPr>
           <a:xfrm>
             <a:off x="18627840" y="10253160"/>
-            <a:ext cx="1201320" cy="860400"/>
+            <a:ext cx="1200240" cy="859320"/>
           </a:xfrm>
           <a:prstGeom prst="rect">
             <a:avLst/>
@@ -20467,7 +20168,7 @@
                 <a:tab algn="l" pos="0"/>
               </a:tabLst>
             </a:pPr>
-            <a:fld id="{C37C6C01-3077-48F0-93F7-3AD98BC35DCC}" type="slidenum">
+            <a:fld id="{7BD0311E-E008-4746-8CA8-F43EB1583824}" type="slidenum">
               <a:rPr b="0" lang="en-IN" sz="2200" spc="-1" strike="noStrike">
                 <a:solidFill>
                   <a:schemeClr val="dk2"/>
@@ -20495,7 +20196,7 @@
         <p:spPr>
           <a:xfrm>
             <a:off x="5057640" y="290520"/>
-            <a:ext cx="9066960" cy="635760"/>
+            <a:ext cx="9065880" cy="634680"/>
           </a:xfrm>
           <a:prstGeom prst="rect">
             <a:avLst/>
@@ -20551,8 +20252,8 @@
         </p:nvSpPr>
         <p:spPr>
           <a:xfrm>
-            <a:off x="8458200" y="10335240"/>
-            <a:ext cx="2783160" cy="635760"/>
+            <a:off x="9144000" y="10337400"/>
+            <a:ext cx="2782080" cy="634680"/>
           </a:xfrm>
           <a:prstGeom prst="rect">
             <a:avLst/>
@@ -20613,7 +20314,7 @@
         <p:spPr>
           <a:xfrm>
             <a:off x="6708600" y="3200400"/>
-            <a:ext cx="7693200" cy="5821200"/>
+            <a:ext cx="7692120" cy="5820120"/>
           </a:xfrm>
           <a:prstGeom prst="rect">
             <a:avLst/>

</xml_diff>